<commit_message>
Stress-test the Eastern/Western Europe roll-up claim (Q9)
Q3's GROUP BY ROLLUP pools individual respondent rows, implicitly
weighting each country by its Stack Overflow sample size rather than
anything real. Added Q9 to olap_queries.sql to re-aggregate with each
country weighted equally (median of per-country medians): the world
median drops 120.7k -> 102.2k, and the 'Eastern Europe overtakes
Western Europe' claim reverses once countries are weighted equally.

Slide 11 and the conclusions slide are rewritten to present this as
a stress-test rather than assert the unverified pooled claim.
</commit_message>
<xml_diff>
--- a/presentation/TechWorker_DW_Presentation.pptx
+++ b/presentation/TechWorker_DW_Presentation.pptx
@@ -693,7 +693,7 @@
           <a:p>
             <a:r>
               <a:rPr lang="en-US" dirty="0"/>
-              <a:t>Q3: this is the theory moment — ROLLUP mirrors the country→sub-region→region hierarchy designed in the DFM. Say explicitly: conceptual design and querying reconnect here.</a:t>
+              <a:t>This is the critical-thinking moment, not just a SQL trick: we drafted a claim from Q3/ROLLUP, then designed Q9 specifically to stress-test it — and it failed. Western Europe's scarto ~ 0 is the control case: it proves the effect is a real sampling artifact, not a query bug, since a sub-region with balanced country samples is untouched. If asked why not just switch to equal-weighting everywhere: the two methods answer different questions — 'what does the typical respondent see' (pooled) vs 'what does the typical country look like' (equal-weighted) — and we kept both, documented, rather than picking the one that made the better headline.</a:t>
             </a:r>
             <a:endParaRPr lang="en-US" dirty="0"/>
           </a:p>
@@ -2427,7 +2427,7 @@
       </p:sp>
       <p:pic>
         <p:nvPicPr>
-          <p:cNvPr id="3" name="Image 0" descr="/sessions/gifted-beautiful-cerf/mnt/progetto data/charts/2_rank_gains.png">    </p:cNvPr>
+          <p:cNvPr id="3" name="Image 0" descr="/sessions/gifted-beautiful-cerf/mnt/progetto data/3_presentazione_e_demo/charts/2_rank_gains.png">    </p:cNvPr>
           <p:cNvPicPr>
             <a:picLocks noChangeAspect="1"/>
           </p:cNvPicPr>
@@ -2706,7 +2706,7 @@
                 <a:ea typeface="Cambria" pitchFamily="34" charset="-122"/>
                 <a:cs typeface="Cambria" pitchFamily="34" charset="-120"/>
               </a:rPr>
-              <a:t>Roll-up: the geography flips</a:t>
+              <a:t>Roll-up, stress-tested: does the geography really flip?</a:t>
             </a:r>
             <a:endParaRPr lang="en-US" sz="3000" dirty="0"/>
           </a:p>
@@ -2714,7 +2714,7 @@
       </p:sp>
       <p:pic>
         <p:nvPicPr>
-          <p:cNvPr id="3" name="Image 0" descr="/sessions/gifted-beautiful-cerf/mnt/progetto data/charts/3_subregion_rollup.png">    </p:cNvPr>
+          <p:cNvPr id="3" name="Image 0" descr="/sessions/gifted-beautiful-cerf/mnt/progetto data/3_presentazione_e_demo/charts/3_bias_correction.png">    </p:cNvPr>
           <p:cNvPicPr>
             <a:picLocks noChangeAspect="1"/>
           </p:cNvPicPr>
@@ -2769,7 +2769,7 @@
                 <a:ea typeface="Cambria" pitchFamily="34" charset="-122"/>
                 <a:cs typeface="Cambria" pitchFamily="34" charset="-120"/>
               </a:rPr>
-              <a:t>E &gt; W</a:t>
+              <a:t>E &lt; W</a:t>
             </a:r>
             <a:endParaRPr lang="en-US" sz="5400" dirty="0"/>
           </a:p>
@@ -2808,7 +2808,7 @@
                 <a:ea typeface="Calibri" pitchFamily="34" charset="-122"/>
                 <a:cs typeface="Calibri" pitchFamily="34" charset="-120"/>
               </a:rPr>
-              <a:t>Eastern Europe overtakes Western Europe in real terms</a:t>
+              <a:t>not "E &gt; W" as the first pass (pooled) suggested</a:t>
             </a:r>
             <a:endParaRPr lang="en-US" sz="1300" dirty="0"/>
           </a:p>
@@ -2850,7 +2850,7 @@
                 <a:ea typeface="Calibri" pitchFamily="34" charset="-122"/>
                 <a:cs typeface="Calibri" pitchFamily="34" charset="-120"/>
               </a:rPr>
-              <a:t>113.7 k$ vs 107.8 k$ median adjusted: the roll-up along the DFM hierarchy reveals it in one query (GROUP BY ROLLUP).</a:t>
+              <a:t>GROUP BY ROLLUP on the pooled fact rows said Eastern Europe overtakes the West: 113.7 k$ vs 107.8 k$ — but pooling implicitly weights each country by its Stack Overflow respondent count, not by anything real.</a:t>
             </a:r>
             <a:endParaRPr lang="en-US" sz="1250" dirty="0"/>
           </a:p>
@@ -2870,7 +2870,7 @@
                 <a:ea typeface="Calibri" pitchFamily="34" charset="-122"/>
                 <a:cs typeface="Calibri" pitchFamily="34" charset="-120"/>
               </a:rPr>
-              <a:t>Northern America stands alone at 184.7 k$; world median 120.7 k$.</a:t>
+              <a:t>Re-computing with one median per country, then a median of those medians (Q9): Eastern Europe drops to 102.7 k$; Western Europe barely moves (107.8 k$, scarto ~ 0 — its 6 countries have comparable samples, so pooling doesn't distort it there).</a:t>
             </a:r>
             <a:endParaRPr lang="en-US" sz="1250" dirty="0"/>
           </a:p>
@@ -2890,7 +2890,7 @@
                 <a:ea typeface="Calibri" pitchFamily="34" charset="-122"/>
                 <a:cs typeface="Calibri" pitchFamily="34" charset="-120"/>
               </a:rPr>
-              <a:t>Melanesia (n = 2) excluded — the threshold rule at work.</a:t>
+              <a:t>Same direction at world level: pooled median 120.7 k$ falls to 102.2 k$ equally weighted. Both queries stay in the workload, documented — they answer different questions, and only one supports the headline we almost wrote.</a:t>
             </a:r>
             <a:endParaRPr lang="en-US" sz="1250" dirty="0"/>
           </a:p>
@@ -3001,7 +3001,7 @@
       </p:sp>
       <p:pic>
         <p:nvPicPr>
-          <p:cNvPr id="3" name="Image 0" descr="/sessions/gifted-beautiful-cerf/mnt/progetto data/charts/4_experience_heatmap.png">    </p:cNvPr>
+          <p:cNvPr id="3" name="Image 0" descr="/sessions/gifted-beautiful-cerf/mnt/progetto data/3_presentazione_e_demo/charts/4_experience_heatmap.png">    </p:cNvPr>
           <p:cNvPicPr>
             <a:picLocks noChangeAspect="1"/>
           </p:cNvPicPr>
@@ -3288,7 +3288,7 @@
       </p:sp>
       <p:pic>
         <p:nvPicPr>
-          <p:cNvPr id="3" name="Image 0" descr="/sessions/gifted-beautiful-cerf/mnt/progetto data/charts/5_remote_premium.png">    </p:cNvPr>
+          <p:cNvPr id="3" name="Image 0" descr="/sessions/gifted-beautiful-cerf/mnt/progetto data/3_presentazione_e_demo/charts/5_remote_premium.png">    </p:cNvPr>
           <p:cNvPicPr>
             <a:picLocks noChangeAspect="1"/>
           </p:cNvPicPr>
@@ -3575,7 +3575,7 @@
       </p:sp>
       <p:pic>
         <p:nvPicPr>
-          <p:cNvPr id="3" name="Image 0" descr="/sessions/gifted-beautiful-cerf/mnt/progetto data/charts/6_language_premium.png">    </p:cNvPr>
+          <p:cNvPr id="3" name="Image 0" descr="/sessions/gifted-beautiful-cerf/mnt/progetto data/3_presentazione_e_demo/charts/6_language_premium.png">    </p:cNvPr>
           <p:cNvPicPr>
             <a:picLocks noChangeAspect="1"/>
           </p:cNvPicPr>
@@ -4463,7 +4463,7 @@
                 <a:ea typeface="Calibri" pitchFamily="34" charset="-122"/>
                 <a:cs typeface="Calibri" pitchFamily="34" charset="-120"/>
               </a:rPr>
-              <a:t>Cost of living redraws the geography of tech work: Eastern Europe overtakes the West in real terms, and remote work is the multiplier that makes it possible.</a:t>
+              <a:t>Cost of living redraws the geography of tech work — but headline regional claims can be artifacts of how you aggregate; remote work is the one multiplier that holds up under every weighting we tried.</a:t>
             </a:r>
             <a:endParaRPr lang="en-US" sz="1700" dirty="0"/>
           </a:p>
@@ -9013,7 +9013,7 @@
       </p:sp>
       <p:pic>
         <p:nvPicPr>
-          <p:cNvPr id="3" name="Image 0" descr="/sessions/gifted-beautiful-cerf/mnt/progetto data/charts/1_top15_purchasing_power.png">    </p:cNvPr>
+          <p:cNvPr id="3" name="Image 0" descr="/sessions/gifted-beautiful-cerf/mnt/progetto data/3_presentazione_e_demo/charts/1_top15_purchasing_power.png">    </p:cNvPr>
           <p:cNvPicPr>
             <a:picLocks noChangeAspect="1"/>
           </p:cNvPicPr>

</xml_diff>

<commit_message>
Copy edits and consistency fixes
- Tightened wording in README, demo script comments, and slide notes;
  removed minute-by-minute timing labels from demo_live.sql comments.
- README and demo_live.sql still referenced the original 'Eastern Europe
  overtakes Western Europe' claim, superseded by the Q9 finding already
  reflected in slide 11; updated both to match.
- Fixed a few stray punctuation and capitalization issues left over from
  the copy edits, in the pptx (slides 2, 4, 10, 16) and README.
</commit_message>
<xml_diff>
--- a/presentation/TechWorker_DW_Presentation.pptx
+++ b/presentation/TechWorker_DW_Presentation.pptx
@@ -4,6 +4,9 @@
   <p:sldMasterIdLst>
     <p:sldMasterId id="2147483648" r:id="rId1"/>
   </p:sldMasterIdLst>
+  <p:notesMasterIdLst>
+    <p:notesMasterId r:id="rId18"/>
+  </p:notesMasterIdLst>
   <p:sldIdLst>
     <p:sldId id="256" r:id="rId2"/>
     <p:sldId id="257" r:id="rId3"/>
@@ -22,9 +25,6 @@
     <p:sldId id="270" r:id="rId16"/>
     <p:sldId id="271" r:id="rId17"/>
   </p:sldIdLst>
-  <p:notesMasterIdLst>
-    <p:notesMasterId r:id="rId18"/>
-  </p:notesMasterIdLst>
   <p:sldSz cx="12192000" cy="6858000"/>
   <p:notesSz cx="6858000" cy="12192000"/>
   <p:defaultTextStyle>
@@ -119,6 +119,11 @@
       </a:defRPr>
     </a:lvl9pPr>
   </p:defaultTextStyle>
+  <p:extLst>
+    <p:ext uri="{EFAFB233-063F-42B5-8137-9DF3F51BA10A}">
+      <p15:sldGuideLst xmlns:p15="http://schemas.microsoft.com/office/powerpoint/2012/main"/>
+    </p:ext>
+  </p:extLst>
 </p:presentation>
 </file>
 
@@ -144,234 +149,10 @@
           <a:chExt cx="0" cy="0"/>
         </a:xfrm>
       </p:grpSpPr>
-      <p:sp>
-        <p:nvSpPr>
-          <p:cNvPr id="2" name="Header Placeholder 1"/>
-          <p:cNvSpPr>
-            <a:spLocks noGrp="1"/>
-          </p:cNvSpPr>
-          <p:nvPr>
-            <p:ph type="hdr" sz="quarter"/>
-          </p:nvPr>
-        </p:nvSpPr>
-        <p:spPr>
-          <a:xfrm>
-            <a:off x="0" y="0"/>
-            <a:ext cx="2971800" cy="458788"/>
-          </a:xfrm>
-          <a:prstGeom prst="rect">
-            <a:avLst/>
-          </a:prstGeom>
-        </p:spPr>
-        <p:txBody>
-          <a:bodyPr vert="horz" lIns="91440" tIns="45720" rIns="91440" bIns="45720" rtlCol="0"/>
-          <a:lstStyle>
-            <a:lvl1pPr algn="l">
-              <a:defRPr sz="1200"/>
-            </a:lvl1pPr>
-          </a:lstStyle>
-          <a:p>
-            <a:endParaRPr lang="en-US"/>
-          </a:p>
-        </p:txBody>
-      </p:sp>
-      <p:sp>
-        <p:nvSpPr>
-          <p:cNvPr id="3" name="Date Placeholder 2"/>
-          <p:cNvSpPr>
-            <a:spLocks noGrp="1"/>
-          </p:cNvSpPr>
-          <p:nvPr>
-            <p:ph type="dt" idx="1"/>
-          </p:nvPr>
-        </p:nvSpPr>
-        <p:spPr>
-          <a:xfrm>
-            <a:off x="3884613" y="0"/>
-            <a:ext cx="2971800" cy="458788"/>
-          </a:xfrm>
-          <a:prstGeom prst="rect">
-            <a:avLst/>
-          </a:prstGeom>
-        </p:spPr>
-        <p:txBody>
-          <a:bodyPr vert="horz" lIns="91440" tIns="45720" rIns="91440" bIns="45720" rtlCol="0"/>
-          <a:lstStyle>
-            <a:lvl1pPr algn="r">
-              <a:defRPr sz="1200"/>
-            </a:lvl1pPr>
-          </a:lstStyle>
-          <a:p>
-            <a:fld id="{5282F153-3F37-0F45-9E97-73ACFA13230C}" type="datetimeFigureOut">
-              <a:rPr lang="en-US"/>
-              <a:t>7/23/19</a:t>
-            </a:fld>
-            <a:endParaRPr lang="en-US"/>
-          </a:p>
-        </p:txBody>
-      </p:sp>
-      <p:sp>
-        <p:nvSpPr>
-          <p:cNvPr id="4" name="Slide Image Placeholder 3"/>
-          <p:cNvSpPr>
-            <a:spLocks noGrp="1" noRot="1" noChangeAspect="1"/>
-          </p:cNvSpPr>
-          <p:nvPr>
-            <p:ph type="sldImg" idx="2"/>
-          </p:nvPr>
-        </p:nvSpPr>
-        <p:spPr>
-          <a:xfrm>
-            <a:off x="685800" y="1143000"/>
-            <a:ext cx="5486400" cy="3086100"/>
-          </a:xfrm>
-          <a:prstGeom prst="rect">
-            <a:avLst/>
-          </a:prstGeom>
-          <a:noFill/>
-          <a:ln w="12700">
-            <a:solidFill>
-              <a:prstClr val="black"/>
-            </a:solidFill>
-          </a:ln>
-        </p:spPr>
-        <p:txBody>
-          <a:bodyPr vert="horz" lIns="91440" tIns="45720" rIns="91440" bIns="45720" rtlCol="0" anchor="ctr"/>
-          <a:lstStyle/>
-          <a:p>
-            <a:endParaRPr lang="en-US"/>
-          </a:p>
-        </p:txBody>
-      </p:sp>
-      <p:sp>
-        <p:nvSpPr>
-          <p:cNvPr id="5" name="Notes Placeholder 4"/>
-          <p:cNvSpPr>
-            <a:spLocks noGrp="1"/>
-          </p:cNvSpPr>
-          <p:nvPr>
-            <p:ph type="body" sz="quarter" idx="3"/>
-          </p:nvPr>
-        </p:nvSpPr>
-        <p:spPr>
-          <a:xfrm>
-            <a:off x="685800" y="4400550"/>
-            <a:ext cx="5486400" cy="3600450"/>
-          </a:xfrm>
-          <a:prstGeom prst="rect">
-            <a:avLst/>
-          </a:prstGeom>
-        </p:spPr>
-        <p:txBody>
-          <a:bodyPr vert="horz" lIns="91440" tIns="45720" rIns="91440" bIns="45720" rtlCol="0"/>
-          <a:lstStyle/>
-          <a:p>
-            <a:pPr lvl="0"/>
-            <a:r>
-              <a:rPr lang="en-US"/>
-              <a:t>Click to edit Master text styles</a:t>
-            </a:r>
-          </a:p>
-          <a:p>
-            <a:pPr lvl="1"/>
-            <a:r>
-              <a:rPr lang="en-US"/>
-              <a:t>Second level</a:t>
-            </a:r>
-          </a:p>
-          <a:p>
-            <a:pPr lvl="2"/>
-            <a:r>
-              <a:rPr lang="en-US"/>
-              <a:t>Third level</a:t>
-            </a:r>
-          </a:p>
-          <a:p>
-            <a:pPr lvl="3"/>
-            <a:r>
-              <a:rPr lang="en-US"/>
-              <a:t>Fourth level</a:t>
-            </a:r>
-          </a:p>
-          <a:p>
-            <a:pPr lvl="4"/>
-            <a:r>
-              <a:rPr lang="en-US"/>
-              <a:t>Fifth level</a:t>
-            </a:r>
-          </a:p>
-        </p:txBody>
-      </p:sp>
-      <p:sp>
-        <p:nvSpPr>
-          <p:cNvPr id="6" name="Footer Placeholder 5"/>
-          <p:cNvSpPr>
-            <a:spLocks noGrp="1"/>
-          </p:cNvSpPr>
-          <p:nvPr>
-            <p:ph type="ftr" sz="quarter" idx="4"/>
-          </p:nvPr>
-        </p:nvSpPr>
-        <p:spPr>
-          <a:xfrm>
-            <a:off x="0" y="8685213"/>
-            <a:ext cx="2971800" cy="458787"/>
-          </a:xfrm>
-          <a:prstGeom prst="rect">
-            <a:avLst/>
-          </a:prstGeom>
-        </p:spPr>
-        <p:txBody>
-          <a:bodyPr vert="horz" lIns="91440" tIns="45720" rIns="91440" bIns="45720" rtlCol="0" anchor="b"/>
-          <a:lstStyle>
-            <a:lvl1pPr algn="l">
-              <a:defRPr sz="1200"/>
-            </a:lvl1pPr>
-          </a:lstStyle>
-          <a:p>
-            <a:endParaRPr lang="en-US"/>
-          </a:p>
-        </p:txBody>
-      </p:sp>
-      <p:sp>
-        <p:nvSpPr>
-          <p:cNvPr id="7" name="Slide Number Placeholder 6"/>
-          <p:cNvSpPr>
-            <a:spLocks noGrp="1"/>
-          </p:cNvSpPr>
-          <p:nvPr>
-            <p:ph type="sldNum" sz="quarter" idx="5"/>
-          </p:nvPr>
-        </p:nvSpPr>
-        <p:spPr>
-          <a:xfrm>
-            <a:off x="3884613" y="8685213"/>
-            <a:ext cx="2971800" cy="458787"/>
-          </a:xfrm>
-          <a:prstGeom prst="rect">
-            <a:avLst/>
-          </a:prstGeom>
-        </p:spPr>
-        <p:txBody>
-          <a:bodyPr vert="horz" lIns="91440" tIns="45720" rIns="91440" bIns="45720" rtlCol="0" anchor="b"/>
-          <a:lstStyle>
-            <a:lvl1pPr algn="r">
-              <a:defRPr sz="1200"/>
-            </a:lvl1pPr>
-          </a:lstStyle>
-          <a:p>
-            <a:fld id="{CE5E9CC1-C706-0F49-92D6-E571CC5EEA8F}" type="slidenum">
-              <a:rPr lang="en-US"/>
-              <a:t>‹#›</a:t>
-            </a:fld>
-            <a:endParaRPr lang="en-US"/>
-          </a:p>
-        </p:txBody>
-      </p:sp>
     </p:spTree>
     <p:extLst>
       <p:ext uri="{BB962C8B-B14F-4D97-AF65-F5344CB8AC3E}">
-        <p14:creationId xmlns:p14="http://schemas.microsoft.com/office/powerpoint/2010/main" val="1024086991"/>
+        <p14:creationId xmlns:p14="http://schemas.microsoft.com/office/powerpoint/2010/main" val="1703186133"/>
       </p:ext>
     </p:extLst>
   </p:cSld>
@@ -519,7 +300,6 @@
               <a:rPr lang="en-US" dirty="0"/>
               <a:t>Introduce yourselves. One sentence: we built a data warehouse that answers where a tech salary actually buys the most, integrating survey, geographic and cost-of-living data. Agenda implicit: sources, design, ETL, results, demo.</a:t>
             </a:r>
-            <a:endParaRPr lang="en-US" dirty="0"/>
           </a:p>
         </p:txBody>
       </p:sp>
@@ -607,7 +387,6 @@
               <a:rPr lang="en-US" dirty="0"/>
               <a:t>Q2, RANK() OVER on nominal vs adjusted medians. This is 'the phenomenon not explicitly evident from the data' the project brief asks for. Ukraine's n makes it statistically strong.</a:t>
             </a:r>
-            <a:endParaRPr lang="en-US" dirty="0"/>
           </a:p>
         </p:txBody>
       </p:sp>
@@ -695,7 +474,6 @@
               <a:rPr lang="en-US" dirty="0"/>
               <a:t>This is the critical-thinking moment, not just a SQL trick: we drafted a claim from Q3/ROLLUP, then designed Q9 specifically to stress-test it — and it failed. Western Europe's scarto ~ 0 is the control case: it proves the effect is a real sampling artifact, not a query bug, since a sub-region with balanced country samples is untouched. If asked why not just switch to equal-weighting everywhere: the two methods answer different questions — 'what does the typical respondent see' (pooled) vs 'what does the typical country look like' (equal-weighted) — and we kept both, documented, rather than picking the one that made the better headline.</a:t>
             </a:r>
-            <a:endParaRPr lang="en-US" dirty="0"/>
           </a:p>
         </p:txBody>
       </p:sp>
@@ -783,7 +561,6 @@
               <a:rPr lang="en-US" dirty="0"/>
               <a:t>Q4. The banding (Junior/Mid/Senior/Expert) is a designed hierarchy over YearsCodePro — thresholds documented, changeable without touching facts. Steepest slopes in emerging markets.</a:t>
             </a:r>
-            <a:endParaRPr lang="en-US" dirty="0"/>
           </a:p>
         </p:txBody>
       </p:sp>
@@ -871,7 +648,6 @@
               <a:rPr lang="en-US" dirty="0"/>
               <a:t>Q6, FILTER conditional medians. This is the mechanism behind the hidden winners: remote pay + low local costs. Tie back to slide 10.</a:t>
             </a:r>
-            <a:endParaRPr lang="en-US" dirty="0"/>
           </a:p>
         </p:txBody>
       </p:sp>
@@ -959,7 +735,6 @@
               <a:rPr lang="en-US" dirty="0"/>
               <a:t>Q7. Declare the double-counting rule before anyone asks. And say 'correlation, not causation' about Erlang — it defuses the obvious objection.</a:t>
             </a:r>
-            <a:endParaRPr lang="en-US" dirty="0"/>
           </a:p>
         </p:txBody>
       </p:sp>
@@ -1047,7 +822,6 @@
               <a:rPr lang="en-US" dirty="0"/>
               <a:t>State limitations before being asked — it demonstrates critical awareness. Each one has a mitigation: trimming, thresholds + large-sample confirmation, explicit caveat, deliberate design choice.</a:t>
             </a:r>
-            <a:endParaRPr lang="en-US" dirty="0"/>
           </a:p>
         </p:txBody>
       </p:sp>
@@ -1135,7 +909,6 @@
               <a:rPr lang="en-US" dirty="0"/>
               <a:t>Close in under 30 seconds and hand over to the demo: 'let us show you the warehouse answering live'. The demo script takes over from here (D1→D5).</a:t>
             </a:r>
-            <a:endParaRPr lang="en-US" dirty="0"/>
           </a:p>
         </p:txBody>
       </p:sp>
@@ -1223,7 +996,6 @@
               <a:rPr lang="en-US" dirty="0"/>
               <a:t>Motivation: comparing tech salaries across countries is meaningless in nominal terms. Our DW adjusts by cost of living. The three numbers: raw volume, sources, final analyzable coverage.</a:t>
             </a:r>
-            <a:endParaRPr lang="en-US" dirty="0"/>
           </a:p>
         </p:txBody>
       </p:sp>
@@ -1311,7 +1083,6 @@
               <a:rPr lang="en-US" dirty="0"/>
               <a:t>One sentence per source. Stress the ROLES: facts / canonical geographic master / context. The master exists because country names are fragile join keys — next slides.</a:t>
             </a:r>
-            <a:endParaRPr lang="en-US" dirty="0"/>
           </a:p>
         </p:txBody>
       </p:sp>
@@ -1399,7 +1170,6 @@
               <a:rPr lang="en-US" dirty="0"/>
               <a:t>Profiling found: implausible self-reported salaries (trim), a heavy-null dimension (Unknown member), and an error inside the geographic master itself (Korea). R4 is a principle: the warehouse never loses information; analytical thresholds live in queries. Median 65k vs mean 86k also motivated median aggregation.</a:t>
             </a:r>
-            <a:endParaRPr lang="en-US" dirty="0"/>
           </a:p>
         </p:txBody>
       </p:sp>
@@ -1487,7 +1257,6 @@
               <a:rPr lang="en-US" dirty="0"/>
               <a:t>Names are the only shared attribute across the three sources — but they are fragile keys. Strategy: converge both sources onto the ISO master once, then join on alpha-3. Tell the Korea story: it proves even the master must be validated. False negatives (Viet Nam vs Vietnam) AND false positives (South Korea/PRK).</a:t>
             </a:r>
-            <a:endParaRPr lang="en-US" dirty="0"/>
           </a:p>
         </p:txBody>
       </p:sp>
@@ -1575,7 +1344,6 @@
               <a:rPr lang="en-US" dirty="0"/>
               <a:t>DFM in official Golfarelli-Rizzi notation: circles = dimensional attributes, underlined = descriptive attributes (ISO code and Numbeo indices on country), (MEDIAN) = aggregation operator declaring non-additivity, double line = multiple arc. Decision D1: indices at country grain live as descriptive attributes; the adjusted measure is pre-computed in ETL.</a:t>
             </a:r>
-            <a:endParaRPr lang="en-US" dirty="0"/>
           </a:p>
         </p:txBody>
       </p:sp>
@@ -1663,7 +1431,6 @@
               <a:rPr lang="en-US" dirty="0"/>
               <a:t>Fact table ~23k rows with FKs to 10 dimensions + two measures; 12 tables total. Why star: normalization protects against update anomalies, which cannot occur in a warehouse written only by controlled ETL — so we trade harmless redundancy for simpler, faster queries.</a:t>
             </a:r>
-            <a:endParaRPr lang="en-US" dirty="0"/>
           </a:p>
         </p:txBody>
       </p:sp>
@@ -1751,7 +1518,6 @@
               <a:rPr lang="en-US" dirty="0"/>
               <a:t>Walk the four stages. Idempotence: rule of reproducibility. Load order: FK integrity. If asked what breaks loading facts first: FK violations — the DDL makes wrong ETL impossible. QC prints expected counts and a smoke-test ranking straight after load.</a:t>
             </a:r>
-            <a:endParaRPr lang="en-US" dirty="0"/>
           </a:p>
         </p:txBody>
       </p:sp>
@@ -1839,7 +1605,6 @@
               <a:rPr lang="en-US" dirty="0"/>
               <a:t>Q1, percentile_cont with HAVING n&gt;=30. The US stays first, but everything below changes vs the nominal ranking. Georgia n=46: above threshold yet flagged — honesty scores points.</a:t>
             </a:r>
-            <a:endParaRPr lang="en-US" dirty="0"/>
           </a:p>
         </p:txBody>
       </p:sp>
@@ -1912,6 +1677,11 @@
 <file path=ppt/slideMasters/slideMaster1.xml><?xml version="1.0" encoding="utf-8"?>
 <p:sldMaster xmlns:a="http://schemas.openxmlformats.org/drawingml/2006/main" xmlns:r="http://schemas.openxmlformats.org/officeDocument/2006/relationships" xmlns:p="http://schemas.openxmlformats.org/presentationml/2006/main">
   <p:cSld>
+    <p:bg>
+      <p:bgRef idx="1001">
+        <a:schemeClr val="bg1"/>
+      </p:bgRef>
+    </p:bg>
     <p:spTree>
       <p:nvGrpSpPr>
         <p:cNvPr id="1" name=""/>
@@ -2194,6 +1964,7 @@
         <a:solidFill>
           <a:srgbClr val="5C1119"/>
         </a:solidFill>
+        <a:effectLst/>
       </p:bgPr>
     </p:bg>
     <p:spTree>
@@ -2231,7 +2002,7 @@
           <a:bodyPr wrap="square" lIns="0" tIns="0" rIns="0" bIns="0" rtlCol="0" anchor="ctr"/>
           <a:lstStyle/>
           <a:p>
-            <a:pPr indent="0" marL="0">
+            <a:pPr marL="0" indent="0">
               <a:buNone/>
             </a:pPr>
             <a:r>
@@ -2248,7 +2019,7 @@
             <a:endParaRPr lang="en-US" sz="5200" dirty="0"/>
           </a:p>
           <a:p>
-            <a:pPr indent="0" marL="0">
+            <a:pPr marL="0" indent="0">
               <a:buNone/>
             </a:pPr>
             <a:r>
@@ -2287,7 +2058,7 @@
           <a:bodyPr wrap="square" lIns="0" tIns="0" rIns="0" bIns="0" rtlCol="0" anchor="ctr"/>
           <a:lstStyle/>
           <a:p>
-            <a:pPr indent="0" marL="0">
+            <a:pPr marL="0" indent="0">
               <a:buNone/>
             </a:pPr>
             <a:r>
@@ -2299,7 +2070,7 @@
                 <a:ea typeface="Calibri" pitchFamily="34" charset="-122"/>
                 <a:cs typeface="Calibri" pitchFamily="34" charset="-120"/>
               </a:rPr>
-              <a:t>A Data Warehousing project — from three heterogeneous sources to OLAP answers</a:t>
+              <a:t>A Data Warehousing project: from three heterogeneous sources to OLAP answers</a:t>
             </a:r>
             <a:endParaRPr lang="en-US" sz="1900" dirty="0"/>
           </a:p>
@@ -2326,7 +2097,7 @@
           <a:bodyPr wrap="square" lIns="0" tIns="0" rIns="0" bIns="0" rtlCol="0" anchor="ctr"/>
           <a:lstStyle/>
           <a:p>
-            <a:pPr indent="0" marL="0">
+            <a:pPr marL="0" indent="0">
               <a:buNone/>
             </a:pPr>
             <a:r>
@@ -2343,7 +2114,7 @@
             <a:endParaRPr lang="en-US" sz="1700" dirty="0"/>
           </a:p>
           <a:p>
-            <a:pPr indent="0" marL="0">
+            <a:pPr marL="0" indent="0">
               <a:buNone/>
             </a:pPr>
             <a:r>
@@ -2407,7 +2178,7 @@
           <a:bodyPr wrap="square" lIns="0" tIns="0" rIns="0" bIns="0" rtlCol="0" anchor="ctr"/>
           <a:lstStyle/>
           <a:p>
-            <a:pPr indent="0" marL="0">
+            <a:pPr marL="0" indent="0">
               <a:buNone/>
             </a:pPr>
             <a:r>
@@ -2427,14 +2198,14 @@
       </p:sp>
       <p:pic>
         <p:nvPicPr>
-          <p:cNvPr id="3" name="Image 0" descr="/sessions/gifted-beautiful-cerf/mnt/progetto data/3_presentazione_e_demo/charts/2_rank_gains.png">    </p:cNvPr>
+          <p:cNvPr id="3" name="Image 0" descr="/sessions/gifted-beautiful-cerf/mnt/progetto data/3_presentazione_e_demo/charts/2_rank_gains.png"/>
           <p:cNvPicPr>
             <a:picLocks noChangeAspect="1"/>
           </p:cNvPicPr>
           <p:nvPr/>
         </p:nvPicPr>
         <p:blipFill>
-          <a:blip r:embed="rId1"/>
+          <a:blip r:embed="rId3"/>
           <a:stretch>
             <a:fillRect/>
           </a:stretch>
@@ -2470,7 +2241,7 @@
           <a:bodyPr wrap="square" lIns="0" tIns="0" rIns="0" bIns="0" rtlCol="0" anchor="ctr"/>
           <a:lstStyle/>
           <a:p>
-            <a:pPr indent="0" marL="0">
+            <a:pPr marL="0" indent="0">
               <a:buNone/>
             </a:pPr>
             <a:r>
@@ -2509,7 +2280,7 @@
           <a:bodyPr wrap="square" lIns="0" tIns="0" rIns="0" bIns="0" rtlCol="0" anchor="ctr"/>
           <a:lstStyle/>
           <a:p>
-            <a:pPr indent="0" marL="0">
+            <a:pPr marL="0" indent="0">
               <a:buNone/>
             </a:pPr>
             <a:r>
@@ -2548,7 +2319,7 @@
           <a:bodyPr wrap="square" lIns="0" tIns="0" rIns="0" bIns="0" rtlCol="0" anchor="ctr"/>
           <a:lstStyle/>
           <a:p>
-            <a:pPr indent="0" marL="0">
+            <a:pPr marL="0" indent="0">
               <a:spcAft>
                 <a:spcPts val="1000"/>
               </a:spcAft>
@@ -2563,12 +2334,35 @@
                 <a:ea typeface="Calibri" pitchFamily="34" charset="-122"/>
                 <a:cs typeface="Calibri" pitchFamily="34" charset="-120"/>
               </a:rPr>
-              <a:t>China, Argentina and Ukraine climb 25 positions each — Ukraine with a rock-solid n = 1,410.</a:t>
+              <a:t>China, Argentina and Ukraine climb 25 positions each </a:t>
+            </a:r>
+            <a:r>
+              <a:rPr lang="en-US" sz="1250" dirty="0">
+                <a:solidFill>
+                  <a:srgbClr val="1A1A1A"/>
+                </a:solidFill>
+                <a:latin typeface="Calibri" pitchFamily="34" charset="0"/>
+                <a:ea typeface="Calibri" pitchFamily="34" charset="-122"/>
+                <a:cs typeface="Calibri" pitchFamily="34" charset="-120"/>
+                <a:sym typeface="Wingdings" pitchFamily="2" charset="2"/>
+              </a:rPr>
+              <a:t></a:t>
+            </a:r>
+            <a:r>
+              <a:rPr lang="en-US" sz="1250" dirty="0">
+                <a:solidFill>
+                  <a:srgbClr val="1A1A1A"/>
+                </a:solidFill>
+                <a:latin typeface="Calibri" pitchFamily="34" charset="0"/>
+                <a:ea typeface="Calibri" pitchFamily="34" charset="-122"/>
+                <a:cs typeface="Calibri" pitchFamily="34" charset="-120"/>
+              </a:rPr>
+              <a:t> Ukraine with a rock-solid n = 1,410.</a:t>
             </a:r>
             <a:endParaRPr lang="en-US" sz="1250" dirty="0"/>
           </a:p>
           <a:p>
-            <a:pPr indent="0" marL="0">
+            <a:pPr marL="0" indent="0">
               <a:spcAft>
                 <a:spcPts val="1000"/>
               </a:spcAft>
@@ -2588,7 +2382,7 @@
             <a:endParaRPr lang="en-US" sz="1250" dirty="0"/>
           </a:p>
           <a:p>
-            <a:pPr indent="0" marL="0">
+            <a:pPr marL="0" indent="0">
               <a:spcAft>
                 <a:spcPts val="1000"/>
               </a:spcAft>
@@ -2603,7 +2397,7 @@
                 <a:ea typeface="Calibri" pitchFamily="34" charset="-122"/>
                 <a:cs typeface="Calibri" pitchFamily="34" charset="-120"/>
               </a:rPr>
-              <a:t>Window functions (RANK) over the same warehouse — no reload needed.</a:t>
+              <a:t>Window functions (RANK) over the same warehouse. No reload needed.</a:t>
             </a:r>
             <a:endParaRPr lang="en-US" sz="1250" dirty="0"/>
           </a:p>
@@ -2630,7 +2424,7 @@
           <a:bodyPr wrap="square" lIns="0" tIns="0" rIns="0" bIns="0" rtlCol="0" anchor="ctr"/>
           <a:lstStyle/>
           <a:p>
-            <a:pPr indent="0" marL="0">
+            <a:pPr marL="0" indent="0">
               <a:buNone/>
             </a:pPr>
             <a:r>
@@ -2694,7 +2488,7 @@
           <a:bodyPr wrap="square" lIns="0" tIns="0" rIns="0" bIns="0" rtlCol="0" anchor="ctr"/>
           <a:lstStyle/>
           <a:p>
-            <a:pPr indent="0" marL="0">
+            <a:pPr marL="0" indent="0">
               <a:buNone/>
             </a:pPr>
             <a:r>
@@ -2714,14 +2508,14 @@
       </p:sp>
       <p:pic>
         <p:nvPicPr>
-          <p:cNvPr id="3" name="Image 0" descr="/sessions/gifted-beautiful-cerf/mnt/progetto data/3_presentazione_e_demo/charts/3_bias_correction.png">    </p:cNvPr>
+          <p:cNvPr id="3" name="Image 0" descr="/sessions/gifted-beautiful-cerf/mnt/progetto data/3_presentazione_e_demo/charts/3_bias_correction.png"/>
           <p:cNvPicPr>
             <a:picLocks noChangeAspect="1"/>
           </p:cNvPicPr>
           <p:nvPr/>
         </p:nvPicPr>
         <p:blipFill>
-          <a:blip r:embed="rId1"/>
+          <a:blip r:embed="rId3"/>
           <a:stretch>
             <a:fillRect/>
           </a:stretch>
@@ -2757,7 +2551,7 @@
           <a:bodyPr wrap="square" lIns="0" tIns="0" rIns="0" bIns="0" rtlCol="0" anchor="ctr"/>
           <a:lstStyle/>
           <a:p>
-            <a:pPr indent="0" marL="0">
+            <a:pPr marL="0" indent="0">
               <a:buNone/>
             </a:pPr>
             <a:r>
@@ -2796,7 +2590,7 @@
           <a:bodyPr wrap="square" lIns="0" tIns="0" rIns="0" bIns="0" rtlCol="0" anchor="ctr"/>
           <a:lstStyle/>
           <a:p>
-            <a:pPr indent="0" marL="0">
+            <a:pPr marL="0" indent="0">
               <a:buNone/>
             </a:pPr>
             <a:r>
@@ -2835,7 +2629,7 @@
           <a:bodyPr wrap="square" lIns="0" tIns="0" rIns="0" bIns="0" rtlCol="0" anchor="ctr"/>
           <a:lstStyle/>
           <a:p>
-            <a:pPr indent="0" marL="0">
+            <a:pPr marL="0" indent="0">
               <a:spcAft>
                 <a:spcPts val="1000"/>
               </a:spcAft>
@@ -2850,12 +2644,33 @@
                 <a:ea typeface="Calibri" pitchFamily="34" charset="-122"/>
                 <a:cs typeface="Calibri" pitchFamily="34" charset="-120"/>
               </a:rPr>
-              <a:t>GROUP BY ROLLUP on the pooled fact rows said Eastern Europe overtakes the West: 113.7 k$ vs 107.8 k$ — but pooling implicitly weights each country by its Stack Overflow respondent count, not by anything real.</a:t>
+              <a:t>GROUP BY ROLLUP on the pooled fact rows said Eastern Europe overtakes the West: 113.7 k$ vs 107.8 k$ </a:t>
+            </a:r>
+            <a:br>
+              <a:rPr lang="en-US" sz="1250" dirty="0">
+                <a:solidFill>
+                  <a:srgbClr val="1A1A1A"/>
+                </a:solidFill>
+                <a:latin typeface="Calibri" pitchFamily="34" charset="0"/>
+                <a:ea typeface="Calibri" pitchFamily="34" charset="-122"/>
+                <a:cs typeface="Calibri" pitchFamily="34" charset="-120"/>
+              </a:rPr>
+            </a:br>
+            <a:r>
+              <a:rPr lang="en-US" sz="1250" dirty="0">
+                <a:solidFill>
+                  <a:srgbClr val="1A1A1A"/>
+                </a:solidFill>
+                <a:latin typeface="Calibri" pitchFamily="34" charset="0"/>
+                <a:ea typeface="Calibri" pitchFamily="34" charset="-122"/>
+                <a:cs typeface="Calibri" pitchFamily="34" charset="-120"/>
+              </a:rPr>
+              <a:t>But pooling implicitly weights each country by its Stack Overflow respondent count, not by anything real.</a:t>
             </a:r>
             <a:endParaRPr lang="en-US" sz="1250" dirty="0"/>
           </a:p>
           <a:p>
-            <a:pPr indent="0" marL="0">
+            <a:pPr marL="0" indent="0">
               <a:spcAft>
                 <a:spcPts val="1000"/>
               </a:spcAft>
@@ -2870,12 +2685,35 @@
                 <a:ea typeface="Calibri" pitchFamily="34" charset="-122"/>
                 <a:cs typeface="Calibri" pitchFamily="34" charset="-120"/>
               </a:rPr>
-              <a:t>Re-computing with one median per country, then a median of those medians (Q9): Eastern Europe drops to 102.7 k$; Western Europe barely moves (107.8 k$, scarto ~ 0 — its 6 countries have comparable samples, so pooling doesn't distort it there).</a:t>
+              <a:t>Re-computing with one median per country, then a median of those medians (Q9): Eastern Europe drops to 102.7 k$; Western Europe barely moves (107.8 k$, scarto ~ 0 </a:t>
+            </a:r>
+            <a:r>
+              <a:rPr lang="en-US" sz="1250" dirty="0">
+                <a:solidFill>
+                  <a:srgbClr val="1A1A1A"/>
+                </a:solidFill>
+                <a:latin typeface="Calibri" pitchFamily="34" charset="0"/>
+                <a:ea typeface="Calibri" pitchFamily="34" charset="-122"/>
+                <a:cs typeface="Calibri" pitchFamily="34" charset="-120"/>
+                <a:sym typeface="Wingdings" pitchFamily="2" charset="2"/>
+              </a:rPr>
+              <a:t></a:t>
+            </a:r>
+            <a:r>
+              <a:rPr lang="en-US" sz="1250" dirty="0">
+                <a:solidFill>
+                  <a:srgbClr val="1A1A1A"/>
+                </a:solidFill>
+                <a:latin typeface="Calibri" pitchFamily="34" charset="0"/>
+                <a:ea typeface="Calibri" pitchFamily="34" charset="-122"/>
+                <a:cs typeface="Calibri" pitchFamily="34" charset="-120"/>
+              </a:rPr>
+              <a:t> its 6 countries have comparable samples, so pooling doesn't distort it there).</a:t>
             </a:r>
             <a:endParaRPr lang="en-US" sz="1250" dirty="0"/>
           </a:p>
           <a:p>
-            <a:pPr indent="0" marL="0">
+            <a:pPr marL="0" indent="0">
               <a:spcAft>
                 <a:spcPts val="1000"/>
               </a:spcAft>
@@ -2890,7 +2728,7 @@
                 <a:ea typeface="Calibri" pitchFamily="34" charset="-122"/>
                 <a:cs typeface="Calibri" pitchFamily="34" charset="-120"/>
               </a:rPr>
-              <a:t>Same direction at world level: pooled median 120.7 k$ falls to 102.2 k$ equally weighted. Both queries stay in the workload, documented — they answer different questions, and only one supports the headline we almost wrote.</a:t>
+              <a:t>Same direction at world level: pooled median 120.7 k$ falls to 102.2 k$ equally weighted. Both queries stay in the workload, documented; they answer different questions, and only one supports the headline we almost wrote.</a:t>
             </a:r>
             <a:endParaRPr lang="en-US" sz="1250" dirty="0"/>
           </a:p>
@@ -2917,7 +2755,7 @@
           <a:bodyPr wrap="square" lIns="0" tIns="0" rIns="0" bIns="0" rtlCol="0" anchor="ctr"/>
           <a:lstStyle/>
           <a:p>
-            <a:pPr indent="0" marL="0">
+            <a:pPr marL="0" indent="0">
               <a:buNone/>
             </a:pPr>
             <a:r>
@@ -2981,7 +2819,7 @@
           <a:bodyPr wrap="square" lIns="0" tIns="0" rIns="0" bIns="0" rtlCol="0" anchor="ctr"/>
           <a:lstStyle/>
           <a:p>
-            <a:pPr indent="0" marL="0">
+            <a:pPr marL="0" indent="0">
               <a:buNone/>
             </a:pPr>
             <a:r>
@@ -2993,7 +2831,7 @@
                 <a:ea typeface="Cambria" pitchFamily="34" charset="-122"/>
                 <a:cs typeface="Cambria" pitchFamily="34" charset="-120"/>
               </a:rPr>
-              <a:t>Experience pays — with very different slopes</a:t>
+              <a:t>Experience pays with very different slopes</a:t>
             </a:r>
             <a:endParaRPr lang="en-US" sz="3000" dirty="0"/>
           </a:p>
@@ -3001,14 +2839,14 @@
       </p:sp>
       <p:pic>
         <p:nvPicPr>
-          <p:cNvPr id="3" name="Image 0" descr="/sessions/gifted-beautiful-cerf/mnt/progetto data/3_presentazione_e_demo/charts/4_experience_heatmap.png">    </p:cNvPr>
+          <p:cNvPr id="3" name="Image 0" descr="/sessions/gifted-beautiful-cerf/mnt/progetto data/3_presentazione_e_demo/charts/4_experience_heatmap.png"/>
           <p:cNvPicPr>
             <a:picLocks noChangeAspect="1"/>
           </p:cNvPicPr>
           <p:nvPr/>
         </p:nvPicPr>
         <p:blipFill>
-          <a:blip r:embed="rId1"/>
+          <a:blip r:embed="rId3"/>
           <a:stretch>
             <a:fillRect/>
           </a:stretch>
@@ -3044,7 +2882,7 @@
           <a:bodyPr wrap="square" lIns="0" tIns="0" rIns="0" bIns="0" rtlCol="0" anchor="ctr"/>
           <a:lstStyle/>
           <a:p>
-            <a:pPr indent="0" marL="0">
+            <a:pPr marL="0" indent="0">
               <a:buNone/>
             </a:pPr>
             <a:r>
@@ -3083,7 +2921,7 @@
           <a:bodyPr wrap="square" lIns="0" tIns="0" rIns="0" bIns="0" rtlCol="0" anchor="ctr"/>
           <a:lstStyle/>
           <a:p>
-            <a:pPr indent="0" marL="0">
+            <a:pPr marL="0" indent="0">
               <a:buNone/>
             </a:pPr>
             <a:r>
@@ -3122,7 +2960,7 @@
           <a:bodyPr wrap="square" lIns="0" tIns="0" rIns="0" bIns="0" rtlCol="0" anchor="ctr"/>
           <a:lstStyle/>
           <a:p>
-            <a:pPr indent="0" marL="0">
+            <a:pPr marL="0" indent="0">
               <a:spcAft>
                 <a:spcPts val="1000"/>
               </a:spcAft>
@@ -3142,7 +2980,7 @@
             <a:endParaRPr lang="en-US" sz="1250" dirty="0"/>
           </a:p>
           <a:p>
-            <a:pPr indent="0" marL="0">
+            <a:pPr marL="0" indent="0">
               <a:spcAft>
                 <a:spcPts val="1000"/>
               </a:spcAft>
@@ -3162,7 +3000,7 @@
             <a:endParaRPr lang="en-US" sz="1250" dirty="0"/>
           </a:p>
           <a:p>
-            <a:pPr indent="0" marL="0">
+            <a:pPr marL="0" indent="0">
               <a:spcAft>
                 <a:spcPts val="1000"/>
               </a:spcAft>
@@ -3204,7 +3042,7 @@
           <a:bodyPr wrap="square" lIns="0" tIns="0" rIns="0" bIns="0" rtlCol="0" anchor="ctr"/>
           <a:lstStyle/>
           <a:p>
-            <a:pPr indent="0" marL="0">
+            <a:pPr marL="0" indent="0">
               <a:buNone/>
             </a:pPr>
             <a:r>
@@ -3268,7 +3106,7 @@
           <a:bodyPr wrap="square" lIns="0" tIns="0" rIns="0" bIns="0" rtlCol="0" anchor="ctr"/>
           <a:lstStyle/>
           <a:p>
-            <a:pPr indent="0" marL="0">
+            <a:pPr marL="0" indent="0">
               <a:buNone/>
             </a:pPr>
             <a:r>
@@ -3288,14 +3126,14 @@
       </p:sp>
       <p:pic>
         <p:nvPicPr>
-          <p:cNvPr id="3" name="Image 0" descr="/sessions/gifted-beautiful-cerf/mnt/progetto data/3_presentazione_e_demo/charts/5_remote_premium.png">    </p:cNvPr>
+          <p:cNvPr id="3" name="Image 0" descr="/sessions/gifted-beautiful-cerf/mnt/progetto data/3_presentazione_e_demo/charts/5_remote_premium.png"/>
           <p:cNvPicPr>
             <a:picLocks noChangeAspect="1"/>
           </p:cNvPicPr>
           <p:nvPr/>
         </p:nvPicPr>
         <p:blipFill>
-          <a:blip r:embed="rId1"/>
+          <a:blip r:embed="rId3"/>
           <a:stretch>
             <a:fillRect/>
           </a:stretch>
@@ -3331,7 +3169,7 @@
           <a:bodyPr wrap="square" lIns="0" tIns="0" rIns="0" bIns="0" rtlCol="0" anchor="ctr"/>
           <a:lstStyle/>
           <a:p>
-            <a:pPr indent="0" marL="0">
+            <a:pPr marL="0" indent="0">
               <a:buNone/>
             </a:pPr>
             <a:r>
@@ -3370,7 +3208,7 @@
           <a:bodyPr wrap="square" lIns="0" tIns="0" rIns="0" bIns="0" rtlCol="0" anchor="ctr"/>
           <a:lstStyle/>
           <a:p>
-            <a:pPr indent="0" marL="0">
+            <a:pPr marL="0" indent="0">
               <a:buNone/>
             </a:pPr>
             <a:r>
@@ -3409,7 +3247,7 @@
           <a:bodyPr wrap="square" lIns="0" tIns="0" rIns="0" bIns="0" rtlCol="0" anchor="ctr"/>
           <a:lstStyle/>
           <a:p>
-            <a:pPr indent="0" marL="0">
+            <a:pPr marL="0" indent="0">
               <a:spcAft>
                 <a:spcPts val="1000"/>
               </a:spcAft>
@@ -3424,12 +3262,12 @@
                 <a:ea typeface="Calibri" pitchFamily="34" charset="-122"/>
                 <a:cs typeface="Calibri" pitchFamily="34" charset="-120"/>
               </a:rPr>
-              <a:t>Remote work decouples the salary from the local market — but not from the local cost of living.</a:t>
+              <a:t>Remote work decouples the salary from the local market but not from the local cost of living.</a:t>
             </a:r>
             <a:endParaRPr lang="en-US" sz="1250" dirty="0"/>
           </a:p>
           <a:p>
-            <a:pPr indent="0" marL="0">
+            <a:pPr marL="0" indent="0">
               <a:spcAft>
                 <a:spcPts val="1000"/>
               </a:spcAft>
@@ -3449,7 +3287,7 @@
             <a:endParaRPr lang="en-US" sz="1250" dirty="0"/>
           </a:p>
           <a:p>
-            <a:pPr indent="0" marL="0">
+            <a:pPr marL="0" indent="0">
               <a:spcAft>
                 <a:spcPts val="1000"/>
               </a:spcAft>
@@ -3491,7 +3329,7 @@
           <a:bodyPr wrap="square" lIns="0" tIns="0" rIns="0" bIns="0" rtlCol="0" anchor="ctr"/>
           <a:lstStyle/>
           <a:p>
-            <a:pPr indent="0" marL="0">
+            <a:pPr marL="0" indent="0">
               <a:buNone/>
             </a:pPr>
             <a:r>
@@ -3555,7 +3393,7 @@
           <a:bodyPr wrap="square" lIns="0" tIns="0" rIns="0" bIns="0" rtlCol="0" anchor="ctr"/>
           <a:lstStyle/>
           <a:p>
-            <a:pPr indent="0" marL="0">
+            <a:pPr marL="0" indent="0">
               <a:buNone/>
             </a:pPr>
             <a:r>
@@ -3575,14 +3413,14 @@
       </p:sp>
       <p:pic>
         <p:nvPicPr>
-          <p:cNvPr id="3" name="Image 0" descr="/sessions/gifted-beautiful-cerf/mnt/progetto data/3_presentazione_e_demo/charts/6_language_premium.png">    </p:cNvPr>
+          <p:cNvPr id="3" name="Image 0" descr="/sessions/gifted-beautiful-cerf/mnt/progetto data/3_presentazione_e_demo/charts/6_language_premium.png"/>
           <p:cNvPicPr>
             <a:picLocks noChangeAspect="1"/>
           </p:cNvPicPr>
           <p:nvPr/>
         </p:nvPicPr>
         <p:blipFill>
-          <a:blip r:embed="rId1"/>
+          <a:blip r:embed="rId3"/>
           <a:stretch>
             <a:fillRect/>
           </a:stretch>
@@ -3618,7 +3456,7 @@
           <a:bodyPr wrap="square" lIns="0" tIns="0" rIns="0" bIns="0" rtlCol="0" anchor="ctr"/>
           <a:lstStyle/>
           <a:p>
-            <a:pPr indent="0" marL="0">
+            <a:pPr marL="0" indent="0">
               <a:buNone/>
             </a:pPr>
             <a:r>
@@ -3657,7 +3495,7 @@
           <a:bodyPr wrap="square" lIns="0" tIns="0" rIns="0" bIns="0" rtlCol="0" anchor="ctr"/>
           <a:lstStyle/>
           <a:p>
-            <a:pPr indent="0" marL="0">
+            <a:pPr marL="0" indent="0">
               <a:buNone/>
             </a:pPr>
             <a:r>
@@ -3669,7 +3507,30 @@
                 <a:ea typeface="Calibri" pitchFamily="34" charset="-122"/>
                 <a:cs typeface="Calibri" pitchFamily="34" charset="-120"/>
               </a:rPr>
-              <a:t>languages per respondent — the many-to-many the bridge resolves</a:t>
+              <a:t>languages per respondent </a:t>
+            </a:r>
+            <a:r>
+              <a:rPr lang="en-US" sz="1300" b="1" dirty="0">
+                <a:solidFill>
+                  <a:srgbClr val="2F3C7E"/>
+                </a:solidFill>
+                <a:latin typeface="Calibri" pitchFamily="34" charset="0"/>
+                <a:ea typeface="Calibri" pitchFamily="34" charset="-122"/>
+                <a:cs typeface="Calibri" pitchFamily="34" charset="-120"/>
+                <a:sym typeface="Wingdings" pitchFamily="2" charset="2"/>
+              </a:rPr>
+              <a:t> </a:t>
+            </a:r>
+            <a:r>
+              <a:rPr lang="en-US" sz="1300" b="1" dirty="0">
+                <a:solidFill>
+                  <a:srgbClr val="2F3C7E"/>
+                </a:solidFill>
+                <a:latin typeface="Calibri" pitchFamily="34" charset="0"/>
+                <a:ea typeface="Calibri" pitchFamily="34" charset="-122"/>
+                <a:cs typeface="Calibri" pitchFamily="34" charset="-120"/>
+              </a:rPr>
+              <a:t>the many-to-many the bridge resolves</a:t>
             </a:r>
             <a:endParaRPr lang="en-US" sz="1300" dirty="0"/>
           </a:p>
@@ -3696,7 +3557,7 @@
           <a:bodyPr wrap="square" lIns="0" tIns="0" rIns="0" bIns="0" rtlCol="0" anchor="ctr"/>
           <a:lstStyle/>
           <a:p>
-            <a:pPr indent="0" marL="0">
+            <a:pPr marL="0" indent="0">
               <a:spcAft>
                 <a:spcPts val="1000"/>
               </a:spcAft>
@@ -3716,7 +3577,7 @@
             <a:endParaRPr lang="en-US" sz="1250" dirty="0"/>
           </a:p>
           <a:p>
-            <a:pPr indent="0" marL="0">
+            <a:pPr marL="0" indent="0">
               <a:spcAft>
                 <a:spcPts val="1000"/>
               </a:spcAft>
@@ -3731,12 +3592,12 @@
                 <a:ea typeface="Calibri" pitchFamily="34" charset="-122"/>
                 <a:cs typeface="Calibri" pitchFamily="34" charset="-120"/>
               </a:rPr>
-              <a:t>Double-counting guard: each respondent contributes to every language they use — medians per group are legitimate, sums across groups are not.</a:t>
+              <a:t>Double-counting guard: each respondent contributes to every language they use; medians per group are legitimate, sums across groups are not.</a:t>
             </a:r>
             <a:endParaRPr lang="en-US" sz="1250" dirty="0"/>
           </a:p>
           <a:p>
-            <a:pPr indent="0" marL="0">
+            <a:pPr marL="0" indent="0">
               <a:spcAft>
                 <a:spcPts val="1000"/>
               </a:spcAft>
@@ -3778,7 +3639,7 @@
           <a:bodyPr wrap="square" lIns="0" tIns="0" rIns="0" bIns="0" rtlCol="0" anchor="ctr"/>
           <a:lstStyle/>
           <a:p>
-            <a:pPr indent="0" marL="0">
+            <a:pPr marL="0" indent="0">
               <a:buNone/>
             </a:pPr>
             <a:r>
@@ -3842,7 +3703,7 @@
           <a:bodyPr wrap="square" lIns="0" tIns="0" rIns="0" bIns="0" rtlCol="0" anchor="ctr"/>
           <a:lstStyle/>
           <a:p>
-            <a:pPr indent="0" marL="0">
+            <a:pPr marL="0" indent="0">
               <a:buNone/>
             </a:pPr>
             <a:r>
@@ -3879,6 +3740,13 @@
           </a:solidFill>
           <a:ln/>
         </p:spPr>
+        <p:txBody>
+          <a:bodyPr/>
+          <a:lstStyle/>
+          <a:p>
+            <a:endParaRPr lang="it-IT"/>
+          </a:p>
+        </p:txBody>
       </p:sp>
       <p:sp>
         <p:nvSpPr>
@@ -3901,7 +3769,7 @@
           <a:bodyPr wrap="square" lIns="0" tIns="0" rIns="0" bIns="0" rtlCol="0" anchor="ctr"/>
           <a:lstStyle/>
           <a:p>
-            <a:pPr algn="ctr" indent="0" marL="0">
+            <a:pPr marL="0" indent="0" algn="ctr">
               <a:buNone/>
             </a:pPr>
             <a:r>
@@ -3940,7 +3808,7 @@
           <a:bodyPr wrap="square" lIns="0" tIns="0" rIns="0" bIns="0" rtlCol="0" anchor="ctr"/>
           <a:lstStyle/>
           <a:p>
-            <a:pPr indent="0" marL="0">
+            <a:pPr marL="0" indent="0">
               <a:buNone/>
             </a:pPr>
             <a:r>
@@ -3957,7 +3825,7 @@
             <a:endParaRPr lang="en-US" sz="1600" dirty="0"/>
           </a:p>
           <a:p>
-            <a:pPr indent="0" marL="0">
+            <a:pPr marL="0" indent="0">
               <a:buNone/>
             </a:pPr>
             <a:r>
@@ -3994,6 +3862,13 @@
           </a:solidFill>
           <a:ln/>
         </p:spPr>
+        <p:txBody>
+          <a:bodyPr/>
+          <a:lstStyle/>
+          <a:p>
+            <a:endParaRPr lang="it-IT"/>
+          </a:p>
+        </p:txBody>
       </p:sp>
       <p:sp>
         <p:nvSpPr>
@@ -4016,7 +3891,7 @@
           <a:bodyPr wrap="square" lIns="0" tIns="0" rIns="0" bIns="0" rtlCol="0" anchor="ctr"/>
           <a:lstStyle/>
           <a:p>
-            <a:pPr algn="ctr" indent="0" marL="0">
+            <a:pPr marL="0" indent="0" algn="ctr">
               <a:buNone/>
             </a:pPr>
             <a:r>
@@ -4055,7 +3930,7 @@
           <a:bodyPr wrap="square" lIns="0" tIns="0" rIns="0" bIns="0" rtlCol="0" anchor="ctr"/>
           <a:lstStyle/>
           <a:p>
-            <a:pPr indent="0" marL="0">
+            <a:pPr marL="0" indent="0">
               <a:buNone/>
             </a:pPr>
             <a:r>
@@ -4072,7 +3947,7 @@
             <a:endParaRPr lang="en-US" sz="1600" dirty="0"/>
           </a:p>
           <a:p>
-            <a:pPr indent="0" marL="0">
+            <a:pPr marL="0" indent="0">
               <a:buNone/>
             </a:pPr>
             <a:r>
@@ -4084,7 +3959,30 @@
                 <a:ea typeface="Calibri" pitchFamily="34" charset="-122"/>
                 <a:cs typeface="Calibri" pitchFamily="34" charset="-120"/>
               </a:rPr>
-              <a:t>Georgia n=46, Uruguay n=37: above threshold, still fragile — the pattern is confirmed by large samples (Poland 581, Ukraine 1,410)</a:t>
+              <a:t>Georgia n=46, Uruguay n=37: above threshold, still fragile </a:t>
+            </a:r>
+            <a:r>
+              <a:rPr lang="en-US" sz="1300" dirty="0">
+                <a:solidFill>
+                  <a:srgbClr val="6A6A6A"/>
+                </a:solidFill>
+                <a:latin typeface="Calibri" pitchFamily="34" charset="0"/>
+                <a:ea typeface="Calibri" pitchFamily="34" charset="-122"/>
+                <a:cs typeface="Calibri" pitchFamily="34" charset="-120"/>
+                <a:sym typeface="Wingdings" pitchFamily="2" charset="2"/>
+              </a:rPr>
+              <a:t> </a:t>
+            </a:r>
+            <a:r>
+              <a:rPr lang="en-US" sz="1300" dirty="0">
+                <a:solidFill>
+                  <a:srgbClr val="6A6A6A"/>
+                </a:solidFill>
+                <a:latin typeface="Calibri" pitchFamily="34" charset="0"/>
+                <a:ea typeface="Calibri" pitchFamily="34" charset="-122"/>
+                <a:cs typeface="Calibri" pitchFamily="34" charset="-120"/>
+              </a:rPr>
+              <a:t> the pattern is confirmed by large samples (Poland 581, Ukraine 1,410)</a:t>
             </a:r>
             <a:endParaRPr lang="en-US" sz="1600" dirty="0"/>
           </a:p>
@@ -4109,6 +4007,13 @@
           </a:solidFill>
           <a:ln/>
         </p:spPr>
+        <p:txBody>
+          <a:bodyPr/>
+          <a:lstStyle/>
+          <a:p>
+            <a:endParaRPr lang="it-IT"/>
+          </a:p>
+        </p:txBody>
       </p:sp>
       <p:sp>
         <p:nvSpPr>
@@ -4131,7 +4036,7 @@
           <a:bodyPr wrap="square" lIns="0" tIns="0" rIns="0" bIns="0" rtlCol="0" anchor="ctr"/>
           <a:lstStyle/>
           <a:p>
-            <a:pPr algn="ctr" indent="0" marL="0">
+            <a:pPr marL="0" indent="0" algn="ctr">
               <a:buNone/>
             </a:pPr>
             <a:r>
@@ -4170,7 +4075,7 @@
           <a:bodyPr wrap="square" lIns="0" tIns="0" rIns="0" bIns="0" rtlCol="0" anchor="ctr"/>
           <a:lstStyle/>
           <a:p>
-            <a:pPr indent="0" marL="0">
+            <a:pPr marL="0" indent="0">
               <a:buNone/>
             </a:pPr>
             <a:r>
@@ -4187,7 +4092,7 @@
             <a:endParaRPr lang="en-US" sz="1600" dirty="0"/>
           </a:p>
           <a:p>
-            <a:pPr indent="0" marL="0">
+            <a:pPr marL="0" indent="0">
               <a:buNone/>
             </a:pPr>
             <a:r>
@@ -4224,6 +4129,13 @@
           </a:solidFill>
           <a:ln/>
         </p:spPr>
+        <p:txBody>
+          <a:bodyPr/>
+          <a:lstStyle/>
+          <a:p>
+            <a:endParaRPr lang="it-IT"/>
+          </a:p>
+        </p:txBody>
       </p:sp>
       <p:sp>
         <p:nvSpPr>
@@ -4246,7 +4158,7 @@
           <a:bodyPr wrap="square" lIns="0" tIns="0" rIns="0" bIns="0" rtlCol="0" anchor="ctr"/>
           <a:lstStyle/>
           <a:p>
-            <a:pPr algn="ctr" indent="0" marL="0">
+            <a:pPr marL="0" indent="0" algn="ctr">
               <a:buNone/>
             </a:pPr>
             <a:r>
@@ -4285,7 +4197,7 @@
           <a:bodyPr wrap="square" lIns="0" tIns="0" rIns="0" bIns="0" rtlCol="0" anchor="ctr"/>
           <a:lstStyle/>
           <a:p>
-            <a:pPr indent="0" marL="0">
+            <a:pPr marL="0" indent="0">
               <a:buNone/>
             </a:pPr>
             <a:r>
@@ -4302,7 +4214,7 @@
             <a:endParaRPr lang="en-US" sz="1600" dirty="0"/>
           </a:p>
           <a:p>
-            <a:pPr indent="0" marL="0">
+            <a:pPr marL="0" indent="0">
               <a:buNone/>
             </a:pPr>
             <a:r>
@@ -4341,7 +4253,7 @@
           <a:bodyPr wrap="square" lIns="0" tIns="0" rIns="0" bIns="0" rtlCol="0" anchor="ctr"/>
           <a:lstStyle/>
           <a:p>
-            <a:pPr indent="0" marL="0">
+            <a:pPr marL="0" indent="0">
               <a:buNone/>
             </a:pPr>
             <a:r>
@@ -4375,6 +4287,7 @@
         <a:solidFill>
           <a:srgbClr val="5C1119"/>
         </a:solidFill>
+        <a:effectLst/>
       </p:bgPr>
     </p:bg>
     <p:spTree>
@@ -4412,7 +4325,7 @@
           <a:bodyPr wrap="square" lIns="0" tIns="0" rIns="0" bIns="0" rtlCol="0" anchor="ctr"/>
           <a:lstStyle/>
           <a:p>
-            <a:pPr indent="0" marL="0">
+            <a:pPr marL="0" indent="0">
               <a:buNone/>
             </a:pPr>
             <a:r>
@@ -4451,7 +4364,7 @@
           <a:bodyPr wrap="square" lIns="0" tIns="0" rIns="0" bIns="0" rtlCol="0" anchor="ctr"/>
           <a:lstStyle/>
           <a:p>
-            <a:pPr indent="0" marL="0">
+            <a:pPr marL="0" indent="0">
               <a:buNone/>
             </a:pPr>
             <a:r>
@@ -4463,7 +4376,7 @@
                 <a:ea typeface="Calibri" pitchFamily="34" charset="-122"/>
                 <a:cs typeface="Calibri" pitchFamily="34" charset="-120"/>
               </a:rPr>
-              <a:t>Cost of living redraws the geography of tech work — but headline regional claims can be artifacts of how you aggregate; remote work is the one multiplier that holds up under every weighting we tried.</a:t>
+              <a:t>Cost of living redraws the geography of tech work, but headline regional claims can be artifacts of how you aggregate; remote work is the one multiplier that holds up under every weighting we tried.</a:t>
             </a:r>
             <a:endParaRPr lang="en-US" sz="1700" dirty="0"/>
           </a:p>
@@ -4490,7 +4403,7 @@
           <a:bodyPr wrap="square" lIns="0" tIns="0" rIns="0" bIns="0" rtlCol="0" anchor="ctr"/>
           <a:lstStyle/>
           <a:p>
-            <a:pPr indent="0" marL="0">
+            <a:pPr marL="0" indent="0">
               <a:buNone/>
             </a:pPr>
             <a:r>
@@ -4502,7 +4415,30 @@
                 <a:ea typeface="Calibri" pitchFamily="34" charset="-122"/>
                 <a:cs typeface="Calibri" pitchFamily="34" charset="-120"/>
               </a:rPr>
-              <a:t>Three sources that never met became one consistent star schema — reconciled on ISO codes, cleaned by six documented rules, loaded by one idempotent pipeline.</a:t>
+              <a:t>Three sources that never met became one consistent star schema </a:t>
+            </a:r>
+            <a:r>
+              <a:rPr lang="en-US" sz="1700" dirty="0">
+                <a:solidFill>
+                  <a:srgbClr val="F3E2E5"/>
+                </a:solidFill>
+                <a:latin typeface="Calibri" pitchFamily="34" charset="0"/>
+                <a:ea typeface="Calibri" pitchFamily="34" charset="-122"/>
+                <a:cs typeface="Calibri" pitchFamily="34" charset="-120"/>
+                <a:sym typeface="Wingdings" pitchFamily="2" charset="2"/>
+              </a:rPr>
+              <a:t> </a:t>
+            </a:r>
+            <a:r>
+              <a:rPr lang="en-US" sz="1700" dirty="0">
+                <a:solidFill>
+                  <a:srgbClr val="F3E2E5"/>
+                </a:solidFill>
+                <a:latin typeface="Calibri" pitchFamily="34" charset="0"/>
+                <a:ea typeface="Calibri" pitchFamily="34" charset="-122"/>
+                <a:cs typeface="Calibri" pitchFamily="34" charset="-120"/>
+              </a:rPr>
+              <a:t>reconciled on ISO codes, cleaned by six documented rules, loaded by one idempotent pipeline.</a:t>
             </a:r>
             <a:endParaRPr lang="en-US" sz="1700" dirty="0"/>
           </a:p>
@@ -4529,7 +4465,7 @@
           <a:bodyPr wrap="square" lIns="0" tIns="0" rIns="0" bIns="0" rtlCol="0" anchor="ctr"/>
           <a:lstStyle/>
           <a:p>
-            <a:pPr indent="0" marL="0">
+            <a:pPr marL="0" indent="0">
               <a:buNone/>
             </a:pPr>
             <a:r>
@@ -4541,7 +4477,7 @@
                 <a:ea typeface="Calibri" pitchFamily="34" charset="-122"/>
                 <a:cs typeface="Calibri" pitchFamily="34" charset="-120"/>
               </a:rPr>
-              <a:t>Every number in this deck is one SQL query away — as the live demo is about to show.</a:t>
+              <a:t>Every number in this deck is one SQL query away, as the live demo is about to show.</a:t>
             </a:r>
             <a:endParaRPr lang="en-US" sz="1700" dirty="0"/>
           </a:p>
@@ -4568,6 +4504,13 @@
           </a:solidFill>
           <a:ln/>
         </p:spPr>
+        <p:txBody>
+          <a:bodyPr/>
+          <a:lstStyle/>
+          <a:p>
+            <a:endParaRPr lang="it-IT"/>
+          </a:p>
+        </p:txBody>
       </p:sp>
       <p:sp>
         <p:nvSpPr>
@@ -4590,7 +4533,7 @@
           <a:bodyPr wrap="square" lIns="0" tIns="0" rIns="0" bIns="0" rtlCol="0" anchor="ctr"/>
           <a:lstStyle/>
           <a:p>
-            <a:pPr indent="0" marL="0">
+            <a:pPr marL="0" indent="0">
               <a:buNone/>
             </a:pPr>
             <a:r>
@@ -4602,7 +4545,7 @@
                 <a:ea typeface="Cambria" pitchFamily="34" charset="-122"/>
                 <a:cs typeface="Cambria" pitchFamily="34" charset="-120"/>
               </a:rPr>
-              <a:t>Live demo — the warehouse answering in real time  (5 minutes)</a:t>
+              <a:t>Live demo: the warehouse answering in real time  (5 minutes)</a:t>
             </a:r>
             <a:endParaRPr lang="en-US" sz="2000" dirty="0"/>
           </a:p>
@@ -4654,7 +4597,7 @@
           <a:bodyPr wrap="square" lIns="0" tIns="0" rIns="0" bIns="0" rtlCol="0" anchor="ctr"/>
           <a:lstStyle/>
           <a:p>
-            <a:pPr indent="0" marL="0">
+            <a:pPr marL="0" indent="0">
               <a:buNone/>
             </a:pPr>
             <a:r>
@@ -4693,7 +4636,7 @@
           <a:bodyPr wrap="square" lIns="0" tIns="0" rIns="0" bIns="0" rtlCol="0" anchor="ctr"/>
           <a:lstStyle/>
           <a:p>
-            <a:pPr indent="0" marL="0">
+            <a:pPr marL="0" indent="0">
               <a:buNone/>
             </a:pPr>
             <a:r>
@@ -4732,7 +4675,7 @@
           <a:bodyPr wrap="square" lIns="0" tIns="0" rIns="0" bIns="0" rtlCol="0" anchor="ctr"/>
           <a:lstStyle/>
           <a:p>
-            <a:pPr indent="0" marL="0">
+            <a:pPr marL="0" indent="0">
               <a:buNone/>
             </a:pPr>
             <a:r>
@@ -4744,7 +4687,7 @@
                 <a:ea typeface="Calibri" pitchFamily="34" charset="-122"/>
                 <a:cs typeface="Calibri" pitchFamily="34" charset="-120"/>
               </a:rPr>
-              <a:t>A nominal salary is a misleading signal: 60,000 $ in Zurich and in Buenos Aires are two different lives. To compare countries fairly, salaries must be adjusted for the local cost of living — and that requires integrating data nobody publishes together.</a:t>
+              <a:t>A nominal salary is a misleading signal: 60,000 $ in Zurich and in Buenos Aires are two different lives. To compare countries fairly, salaries must be adjusted for the local cost of living, and that requires integrating data nobody publishes together.</a:t>
             </a:r>
             <a:endParaRPr lang="en-US" sz="1600" dirty="0"/>
           </a:p>
@@ -4771,6 +4714,13 @@
           </a:solidFill>
           <a:ln/>
         </p:spPr>
+        <p:txBody>
+          <a:bodyPr/>
+          <a:lstStyle/>
+          <a:p>
+            <a:endParaRPr lang="it-IT"/>
+          </a:p>
+        </p:txBody>
       </p:sp>
       <p:sp>
         <p:nvSpPr>
@@ -4793,7 +4743,7 @@
           <a:bodyPr wrap="square" lIns="0" tIns="0" rIns="0" bIns="0" rtlCol="0" anchor="ctr"/>
           <a:lstStyle/>
           <a:p>
-            <a:pPr algn="ctr" indent="0" marL="0">
+            <a:pPr marL="0" indent="0" algn="ctr">
               <a:buNone/>
             </a:pPr>
             <a:r>
@@ -4832,7 +4782,7 @@
           <a:bodyPr wrap="square" lIns="0" tIns="0" rIns="0" bIns="0" rtlCol="0" anchor="ctr"/>
           <a:lstStyle/>
           <a:p>
-            <a:pPr algn="ctr" indent="0" marL="0">
+            <a:pPr marL="0" indent="0" algn="ctr">
               <a:buNone/>
             </a:pPr>
             <a:r>
@@ -4849,7 +4799,7 @@
             <a:endParaRPr lang="en-US" sz="1300" dirty="0"/>
           </a:p>
           <a:p>
-            <a:pPr algn="ctr" indent="0" marL="0">
+            <a:pPr marL="0" indent="0" algn="ctr">
               <a:buNone/>
             </a:pPr>
             <a:r>
@@ -4888,6 +4838,13 @@
           </a:solidFill>
           <a:ln/>
         </p:spPr>
+        <p:txBody>
+          <a:bodyPr/>
+          <a:lstStyle/>
+          <a:p>
+            <a:endParaRPr lang="it-IT"/>
+          </a:p>
+        </p:txBody>
       </p:sp>
       <p:sp>
         <p:nvSpPr>
@@ -4910,7 +4867,7 @@
           <a:bodyPr wrap="square" lIns="0" tIns="0" rIns="0" bIns="0" rtlCol="0" anchor="ctr"/>
           <a:lstStyle/>
           <a:p>
-            <a:pPr algn="ctr" indent="0" marL="0">
+            <a:pPr marL="0" indent="0" algn="ctr">
               <a:buNone/>
             </a:pPr>
             <a:r>
@@ -4949,7 +4906,7 @@
           <a:bodyPr wrap="square" lIns="0" tIns="0" rIns="0" bIns="0" rtlCol="0" anchor="ctr"/>
           <a:lstStyle/>
           <a:p>
-            <a:pPr algn="ctr" indent="0" marL="0">
+            <a:pPr marL="0" indent="0" algn="ctr">
               <a:buNone/>
             </a:pPr>
             <a:r>
@@ -4966,7 +4923,7 @@
             <a:endParaRPr lang="en-US" sz="1300" dirty="0"/>
           </a:p>
           <a:p>
-            <a:pPr algn="ctr" indent="0" marL="0">
+            <a:pPr marL="0" indent="0" algn="ctr">
               <a:buNone/>
             </a:pPr>
             <a:r>
@@ -5005,6 +4962,13 @@
           </a:solidFill>
           <a:ln/>
         </p:spPr>
+        <p:txBody>
+          <a:bodyPr/>
+          <a:lstStyle/>
+          <a:p>
+            <a:endParaRPr lang="it-IT"/>
+          </a:p>
+        </p:txBody>
       </p:sp>
       <p:sp>
         <p:nvSpPr>
@@ -5027,7 +4991,7 @@
           <a:bodyPr wrap="square" lIns="0" tIns="0" rIns="0" bIns="0" rtlCol="0" anchor="ctr"/>
           <a:lstStyle/>
           <a:p>
-            <a:pPr algn="ctr" indent="0" marL="0">
+            <a:pPr marL="0" indent="0" algn="ctr">
               <a:buNone/>
             </a:pPr>
             <a:r>
@@ -5066,7 +5030,7 @@
           <a:bodyPr wrap="square" lIns="0" tIns="0" rIns="0" bIns="0" rtlCol="0" anchor="ctr"/>
           <a:lstStyle/>
           <a:p>
-            <a:pPr algn="ctr" indent="0" marL="0">
+            <a:pPr marL="0" indent="0" algn="ctr">
               <a:buNone/>
             </a:pPr>
             <a:r>
@@ -5083,7 +5047,7 @@
             <a:endParaRPr lang="en-US" sz="1300" dirty="0"/>
           </a:p>
           <a:p>
-            <a:pPr algn="ctr" indent="0" marL="0">
+            <a:pPr marL="0" indent="0" algn="ctr">
               <a:buNone/>
             </a:pPr>
             <a:r>
@@ -5122,7 +5086,7 @@
           <a:bodyPr wrap="square" lIns="0" tIns="0" rIns="0" bIns="0" rtlCol="0" anchor="ctr"/>
           <a:lstStyle/>
           <a:p>
-            <a:pPr indent="0" marL="0">
+            <a:pPr marL="0" indent="0">
               <a:buNone/>
             </a:pPr>
             <a:r>
@@ -5186,7 +5150,7 @@
           <a:bodyPr wrap="square" lIns="0" tIns="0" rIns="0" bIns="0" rtlCol="0" anchor="ctr"/>
           <a:lstStyle/>
           <a:p>
-            <a:pPr indent="0" marL="0">
+            <a:pPr marL="0" indent="0">
               <a:buNone/>
             </a:pPr>
             <a:r>
@@ -5225,6 +5189,13 @@
           </a:solidFill>
           <a:ln/>
         </p:spPr>
+        <p:txBody>
+          <a:bodyPr/>
+          <a:lstStyle/>
+          <a:p>
+            <a:endParaRPr lang="it-IT"/>
+          </a:p>
+        </p:txBody>
       </p:sp>
       <p:sp>
         <p:nvSpPr>
@@ -5247,7 +5218,7 @@
           <a:bodyPr wrap="square" lIns="0" tIns="0" rIns="0" bIns="0" rtlCol="0" anchor="ctr"/>
           <a:lstStyle/>
           <a:p>
-            <a:pPr indent="0" marL="0">
+            <a:pPr marL="0" indent="0">
               <a:buNone/>
             </a:pPr>
             <a:r>
@@ -5286,7 +5257,7 @@
           <a:bodyPr wrap="square" lIns="0" tIns="0" rIns="0" bIns="0" rtlCol="0" anchor="ctr"/>
           <a:lstStyle/>
           <a:p>
-            <a:pPr indent="0" marL="0">
+            <a:pPr marL="0" indent="0">
               <a:buNone/>
             </a:pPr>
             <a:r>
@@ -5298,7 +5269,30 @@
                 <a:ea typeface="Calibri" pitchFamily="34" charset="-122"/>
                 <a:cs typeface="Calibri" pitchFamily="34" charset="-120"/>
               </a:rPr>
-              <a:t>PRIMARY — the facts</a:t>
+              <a:t>PRIMARY </a:t>
+            </a:r>
+            <a:r>
+              <a:rPr lang="en-US" sz="1200" b="1" dirty="0">
+                <a:solidFill>
+                  <a:srgbClr val="8C1D2F"/>
+                </a:solidFill>
+                <a:latin typeface="Calibri" pitchFamily="34" charset="0"/>
+                <a:ea typeface="Calibri" pitchFamily="34" charset="-122"/>
+                <a:cs typeface="Calibri" pitchFamily="34" charset="-120"/>
+                <a:sym typeface="Wingdings" pitchFamily="2" charset="2"/>
+              </a:rPr>
+              <a:t> </a:t>
+            </a:r>
+            <a:r>
+              <a:rPr lang="en-US" sz="1200" b="1" dirty="0">
+                <a:solidFill>
+                  <a:srgbClr val="8C1D2F"/>
+                </a:solidFill>
+                <a:latin typeface="Calibri" pitchFamily="34" charset="0"/>
+                <a:ea typeface="Calibri" pitchFamily="34" charset="-122"/>
+                <a:cs typeface="Calibri" pitchFamily="34" charset="-120"/>
+              </a:rPr>
+              <a:t>the facts</a:t>
             </a:r>
             <a:endParaRPr lang="en-US" sz="1200" dirty="0"/>
           </a:p>
@@ -5431,6 +5425,13 @@
           </a:solidFill>
           <a:ln/>
         </p:spPr>
+        <p:txBody>
+          <a:bodyPr/>
+          <a:lstStyle/>
+          <a:p>
+            <a:endParaRPr lang="it-IT"/>
+          </a:p>
+        </p:txBody>
       </p:sp>
       <p:sp>
         <p:nvSpPr>
@@ -5453,7 +5454,7 @@
           <a:bodyPr wrap="square" lIns="0" tIns="0" rIns="0" bIns="0" rtlCol="0" anchor="ctr"/>
           <a:lstStyle/>
           <a:p>
-            <a:pPr indent="0" marL="0">
+            <a:pPr marL="0" indent="0">
               <a:buNone/>
             </a:pPr>
             <a:r>
@@ -5492,7 +5493,7 @@
           <a:bodyPr wrap="square" lIns="0" tIns="0" rIns="0" bIns="0" rtlCol="0" anchor="ctr"/>
           <a:lstStyle/>
           <a:p>
-            <a:pPr indent="0" marL="0">
+            <a:pPr marL="0" indent="0">
               <a:buNone/>
             </a:pPr>
             <a:r>
@@ -5504,7 +5505,30 @@
                 <a:ea typeface="Calibri" pitchFamily="34" charset="-122"/>
                 <a:cs typeface="Calibri" pitchFamily="34" charset="-120"/>
               </a:rPr>
-              <a:t>MASTER — the canonical key</a:t>
+              <a:t>MASTER </a:t>
+            </a:r>
+            <a:r>
+              <a:rPr lang="en-US" sz="1200" b="1" dirty="0">
+                <a:solidFill>
+                  <a:srgbClr val="8C1D2F"/>
+                </a:solidFill>
+                <a:latin typeface="Calibri" pitchFamily="34" charset="0"/>
+                <a:ea typeface="Calibri" pitchFamily="34" charset="-122"/>
+                <a:cs typeface="Calibri" pitchFamily="34" charset="-120"/>
+                <a:sym typeface="Wingdings" pitchFamily="2" charset="2"/>
+              </a:rPr>
+              <a:t> </a:t>
+            </a:r>
+            <a:r>
+              <a:rPr lang="en-US" sz="1200" b="1" dirty="0">
+                <a:solidFill>
+                  <a:srgbClr val="8C1D2F"/>
+                </a:solidFill>
+                <a:latin typeface="Calibri" pitchFamily="34" charset="0"/>
+                <a:ea typeface="Calibri" pitchFamily="34" charset="-122"/>
+                <a:cs typeface="Calibri" pitchFamily="34" charset="-120"/>
+              </a:rPr>
+              <a:t>the canonical key</a:t>
             </a:r>
             <a:endParaRPr lang="en-US" sz="1200" dirty="0"/>
           </a:p>
@@ -5637,6 +5661,13 @@
           </a:solidFill>
           <a:ln/>
         </p:spPr>
+        <p:txBody>
+          <a:bodyPr/>
+          <a:lstStyle/>
+          <a:p>
+            <a:endParaRPr lang="it-IT"/>
+          </a:p>
+        </p:txBody>
       </p:sp>
       <p:sp>
         <p:nvSpPr>
@@ -5659,7 +5690,7 @@
           <a:bodyPr wrap="square" lIns="0" tIns="0" rIns="0" bIns="0" rtlCol="0" anchor="ctr"/>
           <a:lstStyle/>
           <a:p>
-            <a:pPr indent="0" marL="0">
+            <a:pPr marL="0" indent="0">
               <a:buNone/>
             </a:pPr>
             <a:r>
@@ -5698,7 +5729,7 @@
           <a:bodyPr wrap="square" lIns="0" tIns="0" rIns="0" bIns="0" rtlCol="0" anchor="ctr"/>
           <a:lstStyle/>
           <a:p>
-            <a:pPr indent="0" marL="0">
+            <a:pPr marL="0" indent="0">
               <a:buNone/>
             </a:pPr>
             <a:r>
@@ -5710,7 +5741,30 @@
                 <a:ea typeface="Calibri" pitchFamily="34" charset="-122"/>
                 <a:cs typeface="Calibri" pitchFamily="34" charset="-120"/>
               </a:rPr>
-              <a:t>CONTEXT — the adjustment</a:t>
+              <a:t>CONTEXT </a:t>
+            </a:r>
+            <a:r>
+              <a:rPr lang="en-US" sz="1200" b="1" dirty="0">
+                <a:solidFill>
+                  <a:srgbClr val="8C1D2F"/>
+                </a:solidFill>
+                <a:latin typeface="Calibri" pitchFamily="34" charset="0"/>
+                <a:ea typeface="Calibri" pitchFamily="34" charset="-122"/>
+                <a:cs typeface="Calibri" pitchFamily="34" charset="-120"/>
+                <a:sym typeface="Wingdings" pitchFamily="2" charset="2"/>
+              </a:rPr>
+              <a:t> </a:t>
+            </a:r>
+            <a:r>
+              <a:rPr lang="en-US" sz="1200" b="1" dirty="0">
+                <a:solidFill>
+                  <a:srgbClr val="8C1D2F"/>
+                </a:solidFill>
+                <a:latin typeface="Calibri" pitchFamily="34" charset="0"/>
+                <a:ea typeface="Calibri" pitchFamily="34" charset="-122"/>
+                <a:cs typeface="Calibri" pitchFamily="34" charset="-120"/>
+              </a:rPr>
+              <a:t>the adjustment</a:t>
             </a:r>
             <a:endParaRPr lang="en-US" sz="1200" dirty="0"/>
           </a:p>
@@ -5843,7 +5897,7 @@
           <a:bodyPr wrap="square" lIns="0" tIns="0" rIns="0" bIns="0" rtlCol="0" anchor="ctr"/>
           <a:lstStyle/>
           <a:p>
-            <a:pPr indent="0" marL="0">
+            <a:pPr marL="0" indent="0">
               <a:buNone/>
             </a:pPr>
             <a:r>
@@ -5855,7 +5909,7 @@
                 <a:ea typeface="Calibri" pitchFamily="34" charset="-122"/>
                 <a:cs typeface="Calibri" pitchFamily="34" charset="-120"/>
               </a:rPr>
-              <a:t>No source alone can answer the question — the value is in the integration.</a:t>
+              <a:t>No source alone can answer the question, the value is in the integration.</a:t>
             </a:r>
             <a:endParaRPr lang="en-US" sz="1400" dirty="0"/>
           </a:p>
@@ -5882,7 +5936,7 @@
           <a:bodyPr wrap="square" lIns="0" tIns="0" rIns="0" bIns="0" rtlCol="0" anchor="ctr"/>
           <a:lstStyle/>
           <a:p>
-            <a:pPr indent="0" marL="0">
+            <a:pPr marL="0" indent="0">
               <a:buNone/>
             </a:pPr>
             <a:r>
@@ -5946,7 +6000,7 @@
           <a:bodyPr wrap="square" lIns="0" tIns="0" rIns="0" bIns="0" rtlCol="0" anchor="ctr"/>
           <a:lstStyle/>
           <a:p>
-            <a:pPr indent="0" marL="0">
+            <a:pPr marL="0" indent="0">
               <a:buNone/>
             </a:pPr>
             <a:r>
@@ -5985,7 +6039,7 @@
           <a:bodyPr wrap="square" lIns="0" tIns="0" rIns="0" bIns="0" rtlCol="0" anchor="ctr"/>
           <a:lstStyle/>
           <a:p>
-            <a:pPr indent="0" marL="0">
+            <a:pPr marL="0" indent="0">
               <a:buNone/>
             </a:pPr>
             <a:r>
@@ -5997,7 +6051,7 @@
                 <a:ea typeface="Calibri" pitchFamily="34" charset="-122"/>
                 <a:cs typeface="Calibri" pitchFamily="34" charset="-120"/>
               </a:rPr>
-              <a:t>Every rule is documented, motivated, and implemented in the ETL — no silent cleaning.</a:t>
+              <a:t>Every rule is documented, motivated, and implemented in the ETL. No silent cleaning.</a:t>
             </a:r>
             <a:endParaRPr lang="en-US" sz="1400" dirty="0"/>
           </a:p>
@@ -6024,6 +6078,13 @@
           </a:solidFill>
           <a:ln/>
         </p:spPr>
+        <p:txBody>
+          <a:bodyPr/>
+          <a:lstStyle/>
+          <a:p>
+            <a:endParaRPr lang="it-IT"/>
+          </a:p>
+        </p:txBody>
       </p:sp>
       <p:sp>
         <p:nvSpPr>
@@ -6044,6 +6105,13 @@
           </a:solidFill>
           <a:ln/>
         </p:spPr>
+        <p:txBody>
+          <a:bodyPr/>
+          <a:lstStyle/>
+          <a:p>
+            <a:endParaRPr lang="it-IT"/>
+          </a:p>
+        </p:txBody>
       </p:sp>
       <p:sp>
         <p:nvSpPr>
@@ -6066,7 +6134,7 @@
           <a:bodyPr wrap="square" lIns="0" tIns="0" rIns="0" bIns="0" rtlCol="0" anchor="ctr"/>
           <a:lstStyle/>
           <a:p>
-            <a:pPr algn="ctr" indent="0" marL="0">
+            <a:pPr marL="0" indent="0" algn="ctr">
               <a:buNone/>
             </a:pPr>
             <a:r>
@@ -6105,7 +6173,7 @@
           <a:bodyPr wrap="square" lIns="0" tIns="0" rIns="0" bIns="0" rtlCol="0" anchor="ctr"/>
           <a:lstStyle/>
           <a:p>
-            <a:pPr indent="0" marL="0">
+            <a:pPr marL="0" indent="0">
               <a:buNone/>
             </a:pPr>
             <a:r>
@@ -6122,7 +6190,7 @@
             <a:endParaRPr lang="en-US" sz="1350" dirty="0"/>
           </a:p>
           <a:p>
-            <a:pPr indent="0" marL="0">
+            <a:pPr marL="0" indent="0">
               <a:buNone/>
             </a:pPr>
             <a:r>
@@ -6134,7 +6202,52 @@
                 <a:ea typeface="Calibri" pitchFamily="34" charset="-122"/>
                 <a:cs typeface="Calibri" pitchFamily="34" charset="-120"/>
               </a:rPr>
-              <a:t>keep respondents with ConvertedCompYearly — 23,435 of 65,437 (35.8%)</a:t>
+              <a:t>keep respondents with </a:t>
+            </a:r>
+            <a:r>
+              <a:rPr lang="en-US" sz="1150" dirty="0" err="1">
+                <a:solidFill>
+                  <a:srgbClr val="6A6A6A"/>
+                </a:solidFill>
+                <a:latin typeface="Calibri" pitchFamily="34" charset="0"/>
+                <a:ea typeface="Calibri" pitchFamily="34" charset="-122"/>
+                <a:cs typeface="Calibri" pitchFamily="34" charset="-120"/>
+              </a:rPr>
+              <a:t>ConvertedCompYearly</a:t>
+            </a:r>
+            <a:r>
+              <a:rPr lang="en-US" sz="1150" dirty="0">
+                <a:solidFill>
+                  <a:srgbClr val="6A6A6A"/>
+                </a:solidFill>
+                <a:latin typeface="Calibri" pitchFamily="34" charset="0"/>
+                <a:ea typeface="Calibri" pitchFamily="34" charset="-122"/>
+                <a:cs typeface="Calibri" pitchFamily="34" charset="-120"/>
+              </a:rPr>
+              <a:t> </a:t>
+            </a:r>
+            <a:r>
+              <a:rPr lang="en-US" sz="1150" dirty="0">
+                <a:solidFill>
+                  <a:srgbClr val="6A6A6A"/>
+                </a:solidFill>
+                <a:latin typeface="Calibri" pitchFamily="34" charset="0"/>
+                <a:ea typeface="Calibri" pitchFamily="34" charset="-122"/>
+                <a:cs typeface="Calibri" pitchFamily="34" charset="-120"/>
+                <a:sym typeface="Wingdings" pitchFamily="2" charset="2"/>
+              </a:rPr>
+              <a:t> </a:t>
+            </a:r>
+            <a:r>
+              <a:rPr lang="en-US" sz="1150" dirty="0">
+                <a:solidFill>
+                  <a:srgbClr val="6A6A6A"/>
+                </a:solidFill>
+                <a:latin typeface="Calibri" pitchFamily="34" charset="0"/>
+                <a:ea typeface="Calibri" pitchFamily="34" charset="-122"/>
+                <a:cs typeface="Calibri" pitchFamily="34" charset="-120"/>
+              </a:rPr>
+              <a:t>23,435 of 65,437 (35.8%)</a:t>
             </a:r>
             <a:endParaRPr lang="en-US" sz="1350" dirty="0"/>
           </a:p>
@@ -6161,6 +6274,13 @@
           </a:solidFill>
           <a:ln/>
         </p:spPr>
+        <p:txBody>
+          <a:bodyPr/>
+          <a:lstStyle/>
+          <a:p>
+            <a:endParaRPr lang="it-IT"/>
+          </a:p>
+        </p:txBody>
       </p:sp>
       <p:sp>
         <p:nvSpPr>
@@ -6181,6 +6301,13 @@
           </a:solidFill>
           <a:ln/>
         </p:spPr>
+        <p:txBody>
+          <a:bodyPr/>
+          <a:lstStyle/>
+          <a:p>
+            <a:endParaRPr lang="it-IT"/>
+          </a:p>
+        </p:txBody>
       </p:sp>
       <p:sp>
         <p:nvSpPr>
@@ -6203,7 +6330,7 @@
           <a:bodyPr wrap="square" lIns="0" tIns="0" rIns="0" bIns="0" rtlCol="0" anchor="ctr"/>
           <a:lstStyle/>
           <a:p>
-            <a:pPr algn="ctr" indent="0" marL="0">
+            <a:pPr marL="0" indent="0" algn="ctr">
               <a:buNone/>
             </a:pPr>
             <a:r>
@@ -6242,7 +6369,7 @@
           <a:bodyPr wrap="square" lIns="0" tIns="0" rIns="0" bIns="0" rtlCol="0" anchor="ctr"/>
           <a:lstStyle/>
           <a:p>
-            <a:pPr indent="0" marL="0">
+            <a:pPr marL="0" indent="0">
               <a:buNone/>
             </a:pPr>
             <a:r>
@@ -6259,7 +6386,7 @@
             <a:endParaRPr lang="en-US" sz="1350" dirty="0"/>
           </a:p>
           <a:p>
-            <a:pPr indent="0" marL="0">
+            <a:pPr marL="0" indent="0">
               <a:buNone/>
             </a:pPr>
             <a:r>
@@ -6298,6 +6425,13 @@
           </a:solidFill>
           <a:ln/>
         </p:spPr>
+        <p:txBody>
+          <a:bodyPr/>
+          <a:lstStyle/>
+          <a:p>
+            <a:endParaRPr lang="it-IT"/>
+          </a:p>
+        </p:txBody>
       </p:sp>
       <p:sp>
         <p:nvSpPr>
@@ -6318,6 +6452,13 @@
           </a:solidFill>
           <a:ln/>
         </p:spPr>
+        <p:txBody>
+          <a:bodyPr/>
+          <a:lstStyle/>
+          <a:p>
+            <a:endParaRPr lang="it-IT"/>
+          </a:p>
+        </p:txBody>
       </p:sp>
       <p:sp>
         <p:nvSpPr>
@@ -6340,7 +6481,7 @@
           <a:bodyPr wrap="square" lIns="0" tIns="0" rIns="0" bIns="0" rtlCol="0" anchor="ctr"/>
           <a:lstStyle/>
           <a:p>
-            <a:pPr algn="ctr" indent="0" marL="0">
+            <a:pPr marL="0" indent="0" algn="ctr">
               <a:buNone/>
             </a:pPr>
             <a:r>
@@ -6379,7 +6520,7 @@
           <a:bodyPr wrap="square" lIns="0" tIns="0" rIns="0" bIns="0" rtlCol="0" anchor="ctr"/>
           <a:lstStyle/>
           <a:p>
-            <a:pPr indent="0" marL="0">
+            <a:pPr marL="0" indent="0">
               <a:buNone/>
             </a:pPr>
             <a:r>
@@ -6396,7 +6537,7 @@
             <a:endParaRPr lang="en-US" sz="1350" dirty="0"/>
           </a:p>
           <a:p>
-            <a:pPr indent="0" marL="0">
+            <a:pPr marL="0" indent="0">
               <a:buNone/>
             </a:pPr>
             <a:r>
@@ -6408,7 +6549,7 @@
                 <a:ea typeface="Calibri" pitchFamily="34" charset="-122"/>
                 <a:cs typeface="Calibri" pitchFamily="34" charset="-120"/>
               </a:rPr>
-              <a:t>31.8% nulls — nulls become an explicit dimension member, no fact is lost</a:t>
+              <a:t>31.8% nulls that become an explicit dimension member, no fact is lost</a:t>
             </a:r>
             <a:endParaRPr lang="en-US" sz="1350" dirty="0"/>
           </a:p>
@@ -6435,6 +6576,13 @@
           </a:solidFill>
           <a:ln/>
         </p:spPr>
+        <p:txBody>
+          <a:bodyPr/>
+          <a:lstStyle/>
+          <a:p>
+            <a:endParaRPr lang="it-IT"/>
+          </a:p>
+        </p:txBody>
       </p:sp>
       <p:sp>
         <p:nvSpPr>
@@ -6455,6 +6603,13 @@
           </a:solidFill>
           <a:ln/>
         </p:spPr>
+        <p:txBody>
+          <a:bodyPr/>
+          <a:lstStyle/>
+          <a:p>
+            <a:endParaRPr lang="it-IT"/>
+          </a:p>
+        </p:txBody>
       </p:sp>
       <p:sp>
         <p:nvSpPr>
@@ -6477,7 +6632,7 @@
           <a:bodyPr wrap="square" lIns="0" tIns="0" rIns="0" bIns="0" rtlCol="0" anchor="ctr"/>
           <a:lstStyle/>
           <a:p>
-            <a:pPr algn="ctr" indent="0" marL="0">
+            <a:pPr marL="0" indent="0" algn="ctr">
               <a:buNone/>
             </a:pPr>
             <a:r>
@@ -6516,7 +6671,7 @@
           <a:bodyPr wrap="square" lIns="0" tIns="0" rIns="0" bIns="0" rtlCol="0" anchor="ctr"/>
           <a:lstStyle/>
           <a:p>
-            <a:pPr indent="0" marL="0">
+            <a:pPr marL="0" indent="0">
               <a:buNone/>
             </a:pPr>
             <a:r>
@@ -6533,7 +6688,7 @@
             <a:endParaRPr lang="en-US" sz="1350" dirty="0"/>
           </a:p>
           <a:p>
-            <a:pPr indent="0" marL="0">
+            <a:pPr marL="0" indent="0">
               <a:buNone/>
             </a:pPr>
             <a:r>
@@ -6545,7 +6700,30 @@
                 <a:ea typeface="Calibri" pitchFamily="34" charset="-122"/>
                 <a:cs typeface="Calibri" pitchFamily="34" charset="-120"/>
               </a:rPr>
-              <a:t>n ≥ 30 enforced in OLAP (HAVING), never in ETL — the DW keeps full grain</a:t>
+              <a:t>n ≥ 30 enforced in OLAP (HAVING), never in ETL </a:t>
+            </a:r>
+            <a:r>
+              <a:rPr lang="en-US" sz="1150" dirty="0">
+                <a:solidFill>
+                  <a:srgbClr val="6A6A6A"/>
+                </a:solidFill>
+                <a:latin typeface="Calibri" pitchFamily="34" charset="0"/>
+                <a:ea typeface="Calibri" pitchFamily="34" charset="-122"/>
+                <a:cs typeface="Calibri" pitchFamily="34" charset="-120"/>
+                <a:sym typeface="Wingdings" pitchFamily="2" charset="2"/>
+              </a:rPr>
+              <a:t> </a:t>
+            </a:r>
+            <a:r>
+              <a:rPr lang="en-US" sz="1150" dirty="0">
+                <a:solidFill>
+                  <a:srgbClr val="6A6A6A"/>
+                </a:solidFill>
+                <a:latin typeface="Calibri" pitchFamily="34" charset="0"/>
+                <a:ea typeface="Calibri" pitchFamily="34" charset="-122"/>
+                <a:cs typeface="Calibri" pitchFamily="34" charset="-120"/>
+              </a:rPr>
+              <a:t> the DW keeps full grain</a:t>
             </a:r>
             <a:endParaRPr lang="en-US" sz="1350" dirty="0"/>
           </a:p>
@@ -6572,6 +6750,13 @@
           </a:solidFill>
           <a:ln/>
         </p:spPr>
+        <p:txBody>
+          <a:bodyPr/>
+          <a:lstStyle/>
+          <a:p>
+            <a:endParaRPr lang="it-IT"/>
+          </a:p>
+        </p:txBody>
       </p:sp>
       <p:sp>
         <p:nvSpPr>
@@ -6592,6 +6777,13 @@
           </a:solidFill>
           <a:ln/>
         </p:spPr>
+        <p:txBody>
+          <a:bodyPr/>
+          <a:lstStyle/>
+          <a:p>
+            <a:endParaRPr lang="it-IT"/>
+          </a:p>
+        </p:txBody>
       </p:sp>
       <p:sp>
         <p:nvSpPr>
@@ -6614,7 +6806,7 @@
           <a:bodyPr wrap="square" lIns="0" tIns="0" rIns="0" bIns="0" rtlCol="0" anchor="ctr"/>
           <a:lstStyle/>
           <a:p>
-            <a:pPr algn="ctr" indent="0" marL="0">
+            <a:pPr marL="0" indent="0" algn="ctr">
               <a:buNone/>
             </a:pPr>
             <a:r>
@@ -6653,7 +6845,7 @@
           <a:bodyPr wrap="square" lIns="0" tIns="0" rIns="0" bIns="0" rtlCol="0" anchor="ctr"/>
           <a:lstStyle/>
           <a:p>
-            <a:pPr indent="0" marL="0">
+            <a:pPr marL="0" indent="0">
               <a:buNone/>
             </a:pPr>
             <a:r>
@@ -6670,7 +6862,7 @@
             <a:endParaRPr lang="en-US" sz="1350" dirty="0"/>
           </a:p>
           <a:p>
-            <a:pPr indent="0" marL="0">
+            <a:pPr marL="0" indent="0">
               <a:buNone/>
             </a:pPr>
             <a:r>
@@ -6682,7 +6874,7 @@
                 <a:ea typeface="Calibri" pitchFamily="34" charset="-122"/>
                 <a:cs typeface="Calibri" pitchFamily="34" charset="-120"/>
               </a:rPr>
-              <a:t>'Nomadic' (not a country) and Kosovo (no ISO code) — 8 respondents total</a:t>
+              <a:t>'Nomadic' (not a country) and Kosovo (no ISO code): 8 respondents total</a:t>
             </a:r>
             <a:endParaRPr lang="en-US" sz="1350" dirty="0"/>
           </a:p>
@@ -6709,6 +6901,13 @@
           </a:solidFill>
           <a:ln/>
         </p:spPr>
+        <p:txBody>
+          <a:bodyPr/>
+          <a:lstStyle/>
+          <a:p>
+            <a:endParaRPr lang="it-IT"/>
+          </a:p>
+        </p:txBody>
       </p:sp>
       <p:sp>
         <p:nvSpPr>
@@ -6729,6 +6928,13 @@
           </a:solidFill>
           <a:ln/>
         </p:spPr>
+        <p:txBody>
+          <a:bodyPr/>
+          <a:lstStyle/>
+          <a:p>
+            <a:endParaRPr lang="it-IT"/>
+          </a:p>
+        </p:txBody>
       </p:sp>
       <p:sp>
         <p:nvSpPr>
@@ -6751,7 +6957,7 @@
           <a:bodyPr wrap="square" lIns="0" tIns="0" rIns="0" bIns="0" rtlCol="0" anchor="ctr"/>
           <a:lstStyle/>
           <a:p>
-            <a:pPr algn="ctr" indent="0" marL="0">
+            <a:pPr marL="0" indent="0" algn="ctr">
               <a:buNone/>
             </a:pPr>
             <a:r>
@@ -6790,7 +6996,7 @@
           <a:bodyPr wrap="square" lIns="0" tIns="0" rIns="0" bIns="0" rtlCol="0" anchor="ctr"/>
           <a:lstStyle/>
           <a:p>
-            <a:pPr indent="0" marL="0">
+            <a:pPr marL="0" indent="0">
               <a:buNone/>
             </a:pPr>
             <a:r>
@@ -6807,7 +7013,7 @@
             <a:endParaRPr lang="en-US" sz="1350" dirty="0"/>
           </a:p>
           <a:p>
-            <a:pPr indent="0" marL="0">
+            <a:pPr marL="0" indent="0">
               <a:buNone/>
             </a:pPr>
             <a:r>
@@ -6819,7 +7025,30 @@
                 <a:ea typeface="Calibri" pitchFamily="34" charset="-122"/>
                 <a:cs typeface="Calibri" pitchFamily="34" charset="-120"/>
               </a:rPr>
-              <a:t>row named 'South Korea' carried PRK (North Korea!) — renamed, joins on codes</a:t>
+              <a:t>row named 'South Korea' carried PRK (North Korea!) </a:t>
+            </a:r>
+            <a:r>
+              <a:rPr lang="en-US" sz="1150" dirty="0">
+                <a:solidFill>
+                  <a:srgbClr val="6A6A6A"/>
+                </a:solidFill>
+                <a:latin typeface="Calibri" pitchFamily="34" charset="0"/>
+                <a:ea typeface="Calibri" pitchFamily="34" charset="-122"/>
+                <a:cs typeface="Calibri" pitchFamily="34" charset="-120"/>
+                <a:sym typeface="Wingdings" pitchFamily="2" charset="2"/>
+              </a:rPr>
+              <a:t></a:t>
+            </a:r>
+            <a:r>
+              <a:rPr lang="en-US" sz="1150" dirty="0">
+                <a:solidFill>
+                  <a:srgbClr val="6A6A6A"/>
+                </a:solidFill>
+                <a:latin typeface="Calibri" pitchFamily="34" charset="0"/>
+                <a:ea typeface="Calibri" pitchFamily="34" charset="-122"/>
+                <a:cs typeface="Calibri" pitchFamily="34" charset="-120"/>
+              </a:rPr>
+              <a:t> renamed, joins on codes</a:t>
             </a:r>
             <a:endParaRPr lang="en-US" sz="1350" dirty="0"/>
           </a:p>
@@ -6846,7 +7075,7 @@
           <a:bodyPr wrap="square" lIns="0" tIns="0" rIns="0" bIns="0" rtlCol="0" anchor="ctr"/>
           <a:lstStyle/>
           <a:p>
-            <a:pPr indent="0" marL="0">
+            <a:pPr marL="0" indent="0">
               <a:buNone/>
             </a:pPr>
             <a:r>
@@ -6910,7 +7139,7 @@
           <a:bodyPr wrap="square" lIns="0" tIns="0" rIns="0" bIns="0" rtlCol="0" anchor="ctr"/>
           <a:lstStyle/>
           <a:p>
-            <a:pPr indent="0" marL="0">
+            <a:pPr marL="0" indent="0">
               <a:buNone/>
             </a:pPr>
             <a:r>
@@ -6949,6 +7178,13 @@
           </a:solidFill>
           <a:ln/>
         </p:spPr>
+        <p:txBody>
+          <a:bodyPr/>
+          <a:lstStyle/>
+          <a:p>
+            <a:endParaRPr lang="it-IT"/>
+          </a:p>
+        </p:txBody>
       </p:sp>
       <p:sp>
         <p:nvSpPr>
@@ -6971,7 +7207,7 @@
           <a:bodyPr wrap="square" lIns="0" tIns="0" rIns="0" bIns="0" rtlCol="0" anchor="ctr"/>
           <a:lstStyle/>
           <a:p>
-            <a:pPr indent="0" marL="0">
+            <a:pPr marL="0" indent="0">
               <a:buNone/>
             </a:pPr>
             <a:r>
@@ -6988,7 +7224,7 @@
             <a:endParaRPr lang="en-US" sz="1500" dirty="0"/>
           </a:p>
           <a:p>
-            <a:pPr indent="0" marL="0">
+            <a:pPr marL="0" indent="0">
               <a:buNone/>
             </a:pPr>
             <a:r>
@@ -7000,12 +7236,12 @@
                 <a:ea typeface="Calibri" pitchFamily="34" charset="-122"/>
                 <a:cs typeface="Calibri" pitchFamily="34" charset="-120"/>
               </a:rPr>
-              <a:t>country names — 21 variants mapped</a:t>
+              <a:t>country names: 21 variants mapped</a:t>
             </a:r>
             <a:endParaRPr lang="en-US" sz="1500" dirty="0"/>
           </a:p>
           <a:p>
-            <a:pPr indent="0" marL="0">
+            <a:pPr marL="0" indent="0">
               <a:buNone/>
             </a:pPr>
             <a:r>
@@ -7044,6 +7280,13 @@
           </a:solidFill>
           <a:ln/>
         </p:spPr>
+        <p:txBody>
+          <a:bodyPr/>
+          <a:lstStyle/>
+          <a:p>
+            <a:endParaRPr lang="it-IT"/>
+          </a:p>
+        </p:txBody>
       </p:sp>
       <p:sp>
         <p:nvSpPr>
@@ -7066,7 +7309,7 @@
           <a:bodyPr wrap="square" lIns="0" tIns="0" rIns="0" bIns="0" rtlCol="0" anchor="ctr"/>
           <a:lstStyle/>
           <a:p>
-            <a:pPr indent="0" marL="0">
+            <a:pPr marL="0" indent="0">
               <a:buNone/>
             </a:pPr>
             <a:r>
@@ -7083,7 +7326,7 @@
             <a:endParaRPr lang="en-US" sz="1500" dirty="0"/>
           </a:p>
           <a:p>
-            <a:pPr indent="0" marL="0">
+            <a:pPr marL="0" indent="0">
               <a:buNone/>
             </a:pPr>
             <a:r>
@@ -7095,12 +7338,12 @@
                 <a:ea typeface="Calibri" pitchFamily="34" charset="-122"/>
                 <a:cs typeface="Calibri" pitchFamily="34" charset="-120"/>
               </a:rPr>
-              <a:t>country names — 5 variants mapped</a:t>
+              <a:t>country names: 5 variants mapped</a:t>
             </a:r>
             <a:endParaRPr lang="en-US" sz="1500" dirty="0"/>
           </a:p>
           <a:p>
-            <a:pPr indent="0" marL="0">
+            <a:pPr marL="0" indent="0">
               <a:buNone/>
             </a:pPr>
             <a:r>
@@ -7139,6 +7382,13 @@
           </a:solidFill>
           <a:ln/>
         </p:spPr>
+        <p:txBody>
+          <a:bodyPr/>
+          <a:lstStyle/>
+          <a:p>
+            <a:endParaRPr lang="it-IT"/>
+          </a:p>
+        </p:txBody>
       </p:sp>
       <p:sp>
         <p:nvSpPr>
@@ -7161,7 +7411,7 @@
           <a:bodyPr wrap="square" lIns="0" tIns="0" rIns="0" bIns="0" rtlCol="0" anchor="ctr"/>
           <a:lstStyle/>
           <a:p>
-            <a:pPr indent="0" marL="0">
+            <a:pPr marL="0" indent="0">
               <a:buNone/>
             </a:pPr>
             <a:r>
@@ -7178,7 +7428,7 @@
             <a:endParaRPr lang="en-US" sz="1600" dirty="0"/>
           </a:p>
           <a:p>
-            <a:pPr indent="0" marL="0">
+            <a:pPr marL="0" indent="0">
               <a:buNone/>
             </a:pPr>
             <a:r>
@@ -7195,7 +7445,7 @@
             <a:endParaRPr lang="en-US" sz="1600" dirty="0"/>
           </a:p>
           <a:p>
-            <a:pPr indent="0" marL="0">
+            <a:pPr marL="0" indent="0">
               <a:buNone/>
             </a:pPr>
             <a:r>
@@ -7232,6 +7482,13 @@
           </a:solidFill>
           <a:ln/>
         </p:spPr>
+        <p:txBody>
+          <a:bodyPr/>
+          <a:lstStyle/>
+          <a:p>
+            <a:endParaRPr lang="it-IT"/>
+          </a:p>
+        </p:txBody>
       </p:sp>
       <p:sp>
         <p:nvSpPr>
@@ -7252,6 +7509,13 @@
           </a:solidFill>
           <a:ln/>
         </p:spPr>
+        <p:txBody>
+          <a:bodyPr/>
+          <a:lstStyle/>
+          <a:p>
+            <a:endParaRPr lang="it-IT"/>
+          </a:p>
+        </p:txBody>
       </p:sp>
       <p:sp>
         <p:nvSpPr>
@@ -7274,7 +7538,7 @@
           <a:bodyPr wrap="square" lIns="0" tIns="0" rIns="0" bIns="0" rtlCol="0" anchor="ctr"/>
           <a:lstStyle/>
           <a:p>
-            <a:pPr indent="0" marL="0">
+            <a:pPr marL="0" indent="0">
               <a:buNone/>
             </a:pPr>
             <a:r>
@@ -7313,7 +7577,7 @@
           <a:bodyPr wrap="square" lIns="0" tIns="0" rIns="0" bIns="0" rtlCol="0" anchor="ctr"/>
           <a:lstStyle/>
           <a:p>
-            <a:pPr indent="0" marL="0">
+            <a:pPr marL="0" indent="0">
               <a:buNone/>
             </a:pPr>
             <a:r>
@@ -7325,7 +7589,30 @@
                 <a:ea typeface="Calibri" pitchFamily="34" charset="-122"/>
                 <a:cs typeface="Calibri" pitchFamily="34" charset="-120"/>
               </a:rPr>
-              <a:t>SO names matching the cost-of-living source without cleaning — the miss list included the heaviest countries (USA: 4,677 respondents, UK: 1,391)</a:t>
+              <a:t>SO names matching the cost-of-living source without cleaning </a:t>
+            </a:r>
+            <a:r>
+              <a:rPr lang="en-US" sz="1300" dirty="0">
+                <a:solidFill>
+                  <a:srgbClr val="1A1A1A"/>
+                </a:solidFill>
+                <a:latin typeface="Calibri" pitchFamily="34" charset="0"/>
+                <a:ea typeface="Calibri" pitchFamily="34" charset="-122"/>
+                <a:cs typeface="Calibri" pitchFamily="34" charset="-120"/>
+                <a:sym typeface="Wingdings" pitchFamily="2" charset="2"/>
+              </a:rPr>
+              <a:t> </a:t>
+            </a:r>
+            <a:r>
+              <a:rPr lang="en-US" sz="1300" dirty="0">
+                <a:solidFill>
+                  <a:srgbClr val="1A1A1A"/>
+                </a:solidFill>
+                <a:latin typeface="Calibri" pitchFamily="34" charset="0"/>
+                <a:ea typeface="Calibri" pitchFamily="34" charset="-122"/>
+                <a:cs typeface="Calibri" pitchFamily="34" charset="-120"/>
+              </a:rPr>
+              <a:t> the miss list included the heaviest countries (USA: 4,677 respondents, UK: 1,391)</a:t>
             </a:r>
             <a:endParaRPr lang="en-US" sz="1300" dirty="0"/>
           </a:p>
@@ -7352,7 +7639,7 @@
           <a:bodyPr wrap="square" lIns="0" tIns="0" rIns="0" bIns="0" rtlCol="0" anchor="ctr"/>
           <a:lstStyle/>
           <a:p>
-            <a:pPr indent="0" marL="0">
+            <a:pPr marL="0" indent="0">
               <a:buNone/>
             </a:pPr>
             <a:r>
@@ -7391,7 +7678,7 @@
           <a:bodyPr wrap="square" lIns="0" tIns="0" rIns="0" bIns="0" rtlCol="0" anchor="ctr"/>
           <a:lstStyle/>
           <a:p>
-            <a:pPr indent="0" marL="0">
+            <a:pPr marL="0" indent="0">
               <a:buNone/>
             </a:pPr>
             <a:r>
@@ -7430,7 +7717,7 @@
           <a:bodyPr wrap="square" lIns="0" tIns="0" rIns="0" bIns="0" rtlCol="0" anchor="ctr"/>
           <a:lstStyle/>
           <a:p>
-            <a:pPr indent="0" marL="0">
+            <a:pPr marL="0" indent="0">
               <a:buNone/>
             </a:pPr>
             <a:r>
@@ -7469,7 +7756,7 @@
           <a:bodyPr wrap="square" lIns="0" tIns="0" rIns="0" bIns="0" rtlCol="0" anchor="ctr"/>
           <a:lstStyle/>
           <a:p>
-            <a:pPr indent="0" marL="0">
+            <a:pPr marL="0" indent="0">
               <a:buNone/>
             </a:pPr>
             <a:r>
@@ -7481,7 +7768,30 @@
                 <a:ea typeface="Calibri" pitchFamily="34" charset="-122"/>
                 <a:cs typeface="Calibri" pitchFamily="34" charset="-120"/>
               </a:rPr>
-              <a:t>the master itself had a bug: a row named 'South Korea' carrying North Korea's code — names fail silently in both directions, codes don't</a:t>
+              <a:t>the master itself had a bug: a row named 'South Korea' carrying North Korea's code </a:t>
+            </a:r>
+            <a:r>
+              <a:rPr lang="en-US" sz="1300" dirty="0">
+                <a:solidFill>
+                  <a:srgbClr val="1A1A1A"/>
+                </a:solidFill>
+                <a:latin typeface="Calibri" pitchFamily="34" charset="0"/>
+                <a:ea typeface="Calibri" pitchFamily="34" charset="-122"/>
+                <a:cs typeface="Calibri" pitchFamily="34" charset="-120"/>
+                <a:sym typeface="Wingdings" pitchFamily="2" charset="2"/>
+              </a:rPr>
+              <a:t> </a:t>
+            </a:r>
+            <a:r>
+              <a:rPr lang="en-US" sz="1300" dirty="0">
+                <a:solidFill>
+                  <a:srgbClr val="1A1A1A"/>
+                </a:solidFill>
+                <a:latin typeface="Calibri" pitchFamily="34" charset="0"/>
+                <a:ea typeface="Calibri" pitchFamily="34" charset="-122"/>
+                <a:cs typeface="Calibri" pitchFamily="34" charset="-120"/>
+              </a:rPr>
+              <a:t>names fail silently in both directions, codes don't</a:t>
             </a:r>
             <a:endParaRPr lang="en-US" sz="1300" dirty="0"/>
           </a:p>
@@ -7508,7 +7818,7 @@
           <a:bodyPr wrap="square" lIns="0" tIns="0" rIns="0" bIns="0" rtlCol="0" anchor="ctr"/>
           <a:lstStyle/>
           <a:p>
-            <a:pPr indent="0" marL="0">
+            <a:pPr marL="0" indent="0">
               <a:buNone/>
             </a:pPr>
             <a:r>
@@ -7572,7 +7882,7 @@
           <a:bodyPr wrap="square" lIns="0" tIns="0" rIns="0" bIns="0" rtlCol="0" anchor="ctr"/>
           <a:lstStyle/>
           <a:p>
-            <a:pPr indent="0" marL="0">
+            <a:pPr marL="0" indent="0">
               <a:buNone/>
             </a:pPr>
             <a:r>
@@ -7584,7 +7894,7 @@
                 <a:ea typeface="Cambria" pitchFamily="34" charset="-122"/>
                 <a:cs typeface="Cambria" pitchFamily="34" charset="-120"/>
               </a:rPr>
-              <a:t>Conceptual design — the Dimensional Fact Model</a:t>
+              <a:t>Conceptual design: the Dimensional Fact Model</a:t>
             </a:r>
             <a:endParaRPr lang="en-US" sz="3000" dirty="0"/>
           </a:p>
@@ -7592,14 +7902,14 @@
       </p:sp>
       <p:pic>
         <p:nvPicPr>
-          <p:cNvPr id="3" name="Image 0" descr="/sessions/gifted-beautiful-cerf/mnt/outputs/dfm.png">    </p:cNvPr>
+          <p:cNvPr id="3" name="Image 0" descr="/sessions/gifted-beautiful-cerf/mnt/outputs/dfm.png"/>
           <p:cNvPicPr>
             <a:picLocks noChangeAspect="1"/>
           </p:cNvPicPr>
           <p:nvPr/>
         </p:nvPicPr>
         <p:blipFill>
-          <a:blip r:embed="rId1"/>
+          <a:blip r:embed="rId3"/>
           <a:stretch>
             <a:fillRect/>
           </a:stretch>
@@ -7635,7 +7945,7 @@
           <a:bodyPr wrap="square" lIns="0" tIns="0" rIns="0" bIns="0" rtlCol="0" anchor="ctr"/>
           <a:lstStyle/>
           <a:p>
-            <a:pPr indent="0" marL="0">
+            <a:pPr marL="0" indent="0">
               <a:buNone/>
             </a:pPr>
             <a:r>
@@ -7652,7 +7962,7 @@
             <a:endParaRPr lang="en-US" sz="1400" dirty="0"/>
           </a:p>
           <a:p>
-            <a:pPr indent="0" marL="0">
+            <a:pPr marL="0" indent="0">
               <a:buNone/>
             </a:pPr>
             <a:r>
@@ -7664,7 +7974,7 @@
                 <a:ea typeface="Calibri" pitchFamily="34" charset="-122"/>
                 <a:cs typeface="Calibri" pitchFamily="34" charset="-120"/>
               </a:rPr>
-              <a:t>one survey response — the finest available; aggregating is always possible, disaggregating never</a:t>
+              <a:t>one survey response: the finest available; aggregating is always possible, disaggregating never</a:t>
             </a:r>
             <a:endParaRPr lang="en-US" sz="1400" dirty="0"/>
           </a:p>
@@ -7691,7 +8001,7 @@
           <a:bodyPr wrap="square" lIns="0" tIns="0" rIns="0" bIns="0" rtlCol="0" anchor="ctr"/>
           <a:lstStyle/>
           <a:p>
-            <a:pPr indent="0" marL="0">
+            <a:pPr marL="0" indent="0">
               <a:buNone/>
             </a:pPr>
             <a:r>
@@ -7708,7 +8018,7 @@
             <a:endParaRPr lang="en-US" sz="1400" dirty="0"/>
           </a:p>
           <a:p>
-            <a:pPr indent="0" marL="0">
+            <a:pPr marL="0" indent="0">
               <a:buNone/>
             </a:pPr>
             <a:r>
@@ -7747,7 +8057,7 @@
           <a:bodyPr wrap="square" lIns="0" tIns="0" rIns="0" bIns="0" rtlCol="0" anchor="ctr"/>
           <a:lstStyle/>
           <a:p>
-            <a:pPr indent="0" marL="0">
+            <a:pPr marL="0" indent="0">
               <a:buNone/>
             </a:pPr>
             <a:r>
@@ -7764,7 +8074,7 @@
             <a:endParaRPr lang="en-US" sz="1400" dirty="0"/>
           </a:p>
           <a:p>
-            <a:pPr indent="0" marL="0">
+            <a:pPr marL="0" indent="0">
               <a:buNone/>
             </a:pPr>
             <a:r>
@@ -7803,7 +8113,7 @@
           <a:bodyPr wrap="square" lIns="0" tIns="0" rIns="0" bIns="0" rtlCol="0" anchor="ctr"/>
           <a:lstStyle/>
           <a:p>
-            <a:pPr indent="0" marL="0">
+            <a:pPr marL="0" indent="0">
               <a:buNone/>
             </a:pPr>
             <a:r>
@@ -7820,7 +8130,7 @@
             <a:endParaRPr lang="en-US" sz="1400" dirty="0"/>
           </a:p>
           <a:p>
-            <a:pPr indent="0" marL="0">
+            <a:pPr marL="0" indent="0">
               <a:buNone/>
             </a:pPr>
             <a:r>
@@ -7859,7 +8169,7 @@
           <a:bodyPr wrap="square" lIns="0" tIns="0" rIns="0" bIns="0" rtlCol="0" anchor="ctr"/>
           <a:lstStyle/>
           <a:p>
-            <a:pPr indent="0" marL="0">
+            <a:pPr marL="0" indent="0">
               <a:buNone/>
             </a:pPr>
             <a:r>
@@ -7923,7 +8233,7 @@
           <a:bodyPr wrap="square" lIns="0" tIns="0" rIns="0" bIns="0" rtlCol="0" anchor="ctr"/>
           <a:lstStyle/>
           <a:p>
-            <a:pPr indent="0" marL="0">
+            <a:pPr marL="0" indent="0">
               <a:buNone/>
             </a:pPr>
             <a:r>
@@ -7935,7 +8245,7 @@
                 <a:ea typeface="Cambria" pitchFamily="34" charset="-122"/>
                 <a:cs typeface="Cambria" pitchFamily="34" charset="-120"/>
               </a:rPr>
-              <a:t>Logical design — star schema on PostgreSQL</a:t>
+              <a:t>Logical design: star schema on PostgreSQL</a:t>
             </a:r>
             <a:endParaRPr lang="en-US" sz="3000" dirty="0"/>
           </a:p>
@@ -7943,14 +8253,14 @@
       </p:sp>
       <p:pic>
         <p:nvPicPr>
-          <p:cNvPr id="3" name="Image 0" descr="/sessions/gifted-beautiful-cerf/mnt/outputs/star.png">    </p:cNvPr>
+          <p:cNvPr id="3" name="Image 0" descr="/sessions/gifted-beautiful-cerf/mnt/outputs/star.png"/>
           <p:cNvPicPr>
             <a:picLocks noChangeAspect="1"/>
           </p:cNvPicPr>
           <p:nvPr/>
         </p:nvPicPr>
         <p:blipFill>
-          <a:blip r:embed="rId1"/>
+          <a:blip r:embed="rId3"/>
           <a:stretch>
             <a:fillRect/>
           </a:stretch>
@@ -7986,7 +8296,7 @@
           <a:bodyPr wrap="square" lIns="0" tIns="0" rIns="0" bIns="0" rtlCol="0" anchor="ctr"/>
           <a:lstStyle/>
           <a:p>
-            <a:pPr indent="0" marL="0">
+            <a:pPr marL="0" indent="0">
               <a:buNone/>
             </a:pPr>
             <a:r>
@@ -8003,7 +8313,7 @@
             <a:endParaRPr lang="en-US" sz="1400" dirty="0"/>
           </a:p>
           <a:p>
-            <a:pPr indent="0" marL="0">
+            <a:pPr marL="0" indent="0">
               <a:buNone/>
             </a:pPr>
             <a:r>
@@ -8015,7 +8325,7 @@
                 <a:ea typeface="Calibri" pitchFamily="34" charset="-122"/>
                 <a:cs typeface="Calibri" pitchFamily="34" charset="-120"/>
               </a:rPr>
-              <a:t>hierarchies denormalized in the dimension tables: redundancy is harmless in a read-only, ETL-loaded DW — and queries need fewer joins</a:t>
+              <a:t>hierarchies denormalized in the dimension tables: redundancy is harmless in a read-only, ETL-loaded DW and queries need fewer joins</a:t>
             </a:r>
             <a:endParaRPr lang="en-US" sz="1400" dirty="0"/>
           </a:p>
@@ -8042,7 +8352,7 @@
           <a:bodyPr wrap="square" lIns="0" tIns="0" rIns="0" bIns="0" rtlCol="0" anchor="ctr"/>
           <a:lstStyle/>
           <a:p>
-            <a:pPr indent="0" marL="0">
+            <a:pPr marL="0" indent="0">
               <a:buNone/>
             </a:pPr>
             <a:r>
@@ -8059,7 +8369,7 @@
             <a:endParaRPr lang="en-US" sz="1400" dirty="0"/>
           </a:p>
           <a:p>
-            <a:pPr indent="0" marL="0">
+            <a:pPr marL="0" indent="0">
               <a:buNone/>
             </a:pPr>
             <a:r>
@@ -8098,7 +8408,7 @@
           <a:bodyPr wrap="square" lIns="0" tIns="0" rIns="0" bIns="0" rtlCol="0" anchor="ctr"/>
           <a:lstStyle/>
           <a:p>
-            <a:pPr indent="0" marL="0">
+            <a:pPr marL="0" indent="0">
               <a:buNone/>
             </a:pPr>
             <a:r>
@@ -8115,7 +8425,7 @@
             <a:endParaRPr lang="en-US" sz="1400" dirty="0"/>
           </a:p>
           <a:p>
-            <a:pPr indent="0" marL="0">
+            <a:pPr marL="0" indent="0">
               <a:buNone/>
             </a:pPr>
             <a:r>
@@ -8154,7 +8464,7 @@
           <a:bodyPr wrap="square" lIns="0" tIns="0" rIns="0" bIns="0" rtlCol="0" anchor="ctr"/>
           <a:lstStyle/>
           <a:p>
-            <a:pPr indent="0" marL="0">
+            <a:pPr marL="0" indent="0">
               <a:buNone/>
             </a:pPr>
             <a:r>
@@ -8171,7 +8481,7 @@
             <a:endParaRPr lang="en-US" sz="1400" dirty="0"/>
           </a:p>
           <a:p>
-            <a:pPr indent="0" marL="0">
+            <a:pPr marL="0" indent="0">
               <a:buNone/>
             </a:pPr>
             <a:r>
@@ -8210,7 +8520,7 @@
           <a:bodyPr wrap="square" lIns="0" tIns="0" rIns="0" bIns="0" rtlCol="0" anchor="ctr"/>
           <a:lstStyle/>
           <a:p>
-            <a:pPr indent="0" marL="0">
+            <a:pPr marL="0" indent="0">
               <a:buNone/>
             </a:pPr>
             <a:r>
@@ -8274,7 +8584,7 @@
           <a:bodyPr wrap="square" lIns="0" tIns="0" rIns="0" bIns="0" rtlCol="0" anchor="ctr"/>
           <a:lstStyle/>
           <a:p>
-            <a:pPr indent="0" marL="0">
+            <a:pPr marL="0" indent="0">
               <a:buNone/>
             </a:pPr>
             <a:r>
@@ -8286,7 +8596,7 @@
                 <a:ea typeface="Cambria" pitchFamily="34" charset="-122"/>
                 <a:cs typeface="Cambria" pitchFamily="34" charset="-120"/>
               </a:rPr>
-              <a:t>ETL — a single idempotent Python pipeline</a:t>
+              <a:t>ETL: a single idempotent Python pipeline</a:t>
             </a:r>
             <a:endParaRPr lang="en-US" sz="3000" dirty="0"/>
           </a:p>
@@ -8313,6 +8623,13 @@
           </a:solidFill>
           <a:ln/>
         </p:spPr>
+        <p:txBody>
+          <a:bodyPr/>
+          <a:lstStyle/>
+          <a:p>
+            <a:endParaRPr lang="it-IT"/>
+          </a:p>
+        </p:txBody>
       </p:sp>
       <p:sp>
         <p:nvSpPr>
@@ -8335,7 +8652,7 @@
           <a:bodyPr wrap="square" lIns="0" tIns="0" rIns="0" bIns="0" rtlCol="0" anchor="ctr"/>
           <a:lstStyle/>
           <a:p>
-            <a:pPr indent="0" marL="0">
+            <a:pPr marL="0" indent="0">
               <a:buNone/>
             </a:pPr>
             <a:r>
@@ -8352,7 +8669,7 @@
             <a:endParaRPr lang="en-US" sz="1500" dirty="0"/>
           </a:p>
           <a:p>
-            <a:pPr indent="0" marL="0">
+            <a:pPr marL="0" indent="0">
               <a:buNone/>
             </a:pPr>
             <a:r>
@@ -8369,7 +8686,7 @@
             <a:endParaRPr lang="en-US" sz="1500" dirty="0"/>
           </a:p>
           <a:p>
-            <a:pPr indent="0" marL="0">
+            <a:pPr marL="0" indent="0">
               <a:buNone/>
             </a:pPr>
             <a:r>
@@ -8406,6 +8723,13 @@
           </a:solidFill>
           <a:ln/>
         </p:spPr>
+        <p:txBody>
+          <a:bodyPr/>
+          <a:lstStyle/>
+          <a:p>
+            <a:endParaRPr lang="it-IT"/>
+          </a:p>
+        </p:txBody>
       </p:sp>
       <p:sp>
         <p:nvSpPr>
@@ -8428,6 +8752,13 @@
           </a:solidFill>
           <a:ln/>
         </p:spPr>
+        <p:txBody>
+          <a:bodyPr/>
+          <a:lstStyle/>
+          <a:p>
+            <a:endParaRPr lang="it-IT"/>
+          </a:p>
+        </p:txBody>
       </p:sp>
       <p:sp>
         <p:nvSpPr>
@@ -8450,7 +8781,7 @@
           <a:bodyPr wrap="square" lIns="0" tIns="0" rIns="0" bIns="0" rtlCol="0" anchor="ctr"/>
           <a:lstStyle/>
           <a:p>
-            <a:pPr indent="0" marL="0">
+            <a:pPr marL="0" indent="0">
               <a:buNone/>
             </a:pPr>
             <a:r>
@@ -8467,7 +8798,7 @@
             <a:endParaRPr lang="en-US" sz="1500" dirty="0"/>
           </a:p>
           <a:p>
-            <a:pPr indent="0" marL="0">
+            <a:pPr marL="0" indent="0">
               <a:buNone/>
             </a:pPr>
             <a:r>
@@ -8484,7 +8815,7 @@
             <a:endParaRPr lang="en-US" sz="1500" dirty="0"/>
           </a:p>
           <a:p>
-            <a:pPr indent="0" marL="0">
+            <a:pPr marL="0" indent="0">
               <a:buNone/>
             </a:pPr>
             <a:r>
@@ -8501,7 +8832,7 @@
             <a:endParaRPr lang="en-US" sz="1500" dirty="0"/>
           </a:p>
           <a:p>
-            <a:pPr indent="0" marL="0">
+            <a:pPr marL="0" indent="0">
               <a:buNone/>
             </a:pPr>
             <a:r>
@@ -8538,6 +8869,13 @@
           </a:solidFill>
           <a:ln/>
         </p:spPr>
+        <p:txBody>
+          <a:bodyPr/>
+          <a:lstStyle/>
+          <a:p>
+            <a:endParaRPr lang="it-IT"/>
+          </a:p>
+        </p:txBody>
       </p:sp>
       <p:sp>
         <p:nvSpPr>
@@ -8560,6 +8898,13 @@
           </a:solidFill>
           <a:ln/>
         </p:spPr>
+        <p:txBody>
+          <a:bodyPr/>
+          <a:lstStyle/>
+          <a:p>
+            <a:endParaRPr lang="it-IT"/>
+          </a:p>
+        </p:txBody>
       </p:sp>
       <p:sp>
         <p:nvSpPr>
@@ -8582,7 +8927,7 @@
           <a:bodyPr wrap="square" lIns="0" tIns="0" rIns="0" bIns="0" rtlCol="0" anchor="ctr"/>
           <a:lstStyle/>
           <a:p>
-            <a:pPr indent="0" marL="0">
+            <a:pPr marL="0" indent="0">
               <a:buNone/>
             </a:pPr>
             <a:r>
@@ -8599,7 +8944,7 @@
             <a:endParaRPr lang="en-US" sz="1500" dirty="0"/>
           </a:p>
           <a:p>
-            <a:pPr indent="0" marL="0">
+            <a:pPr marL="0" indent="0">
               <a:buNone/>
             </a:pPr>
             <a:r>
@@ -8616,7 +8961,7 @@
             <a:endParaRPr lang="en-US" sz="1500" dirty="0"/>
           </a:p>
           <a:p>
-            <a:pPr indent="0" marL="0">
+            <a:pPr marL="0" indent="0">
               <a:buNone/>
             </a:pPr>
             <a:r>
@@ -8653,6 +8998,13 @@
           </a:solidFill>
           <a:ln/>
         </p:spPr>
+        <p:txBody>
+          <a:bodyPr/>
+          <a:lstStyle/>
+          <a:p>
+            <a:endParaRPr lang="it-IT"/>
+          </a:p>
+        </p:txBody>
       </p:sp>
       <p:sp>
         <p:nvSpPr>
@@ -8675,6 +9027,13 @@
           </a:solidFill>
           <a:ln/>
         </p:spPr>
+        <p:txBody>
+          <a:bodyPr/>
+          <a:lstStyle/>
+          <a:p>
+            <a:endParaRPr lang="it-IT"/>
+          </a:p>
+        </p:txBody>
       </p:sp>
       <p:sp>
         <p:nvSpPr>
@@ -8697,7 +9056,7 @@
           <a:bodyPr wrap="square" lIns="0" tIns="0" rIns="0" bIns="0" rtlCol="0" anchor="ctr"/>
           <a:lstStyle/>
           <a:p>
-            <a:pPr indent="0" marL="0">
+            <a:pPr marL="0" indent="0">
               <a:buNone/>
             </a:pPr>
             <a:r>
@@ -8714,7 +9073,7 @@
             <a:endParaRPr lang="en-US" sz="1500" dirty="0"/>
           </a:p>
           <a:p>
-            <a:pPr indent="0" marL="0">
+            <a:pPr marL="0" indent="0">
               <a:buNone/>
             </a:pPr>
             <a:r>
@@ -8731,7 +9090,7 @@
             <a:endParaRPr lang="en-US" sz="1500" dirty="0"/>
           </a:p>
           <a:p>
-            <a:pPr indent="0" marL="0">
+            <a:pPr marL="0" indent="0">
               <a:buNone/>
             </a:pPr>
             <a:r>
@@ -8770,7 +9129,7 @@
           <a:bodyPr wrap="square" lIns="0" tIns="0" rIns="0" bIns="0" rtlCol="0" anchor="ctr"/>
           <a:lstStyle/>
           <a:p>
-            <a:pPr indent="0" marL="0">
+            <a:pPr marL="0" indent="0">
               <a:buNone/>
             </a:pPr>
             <a:r>
@@ -8784,9 +9143,6 @@
               </a:rPr>
               <a:t>Idempotent by design — </a:t>
             </a:r>
-            <a:pPr indent="0" marL="0">
-              <a:buNone/>
-            </a:pPr>
             <a:r>
               <a:rPr lang="en-US" sz="1300" dirty="0">
                 <a:solidFill>
@@ -8796,7 +9152,30 @@
                 <a:ea typeface="Calibri" pitchFamily="34" charset="-122"/>
                 <a:cs typeface="Calibri" pitchFamily="34" charset="-120"/>
               </a:rPr>
-              <a:t>every run rebuilds the schema from scratch (DROP SCHEMA … CASCADE) — re-running N times yields the same warehouse. No manual updates, ever: the DW is non-volatile.</a:t>
+              <a:t>every run rebuilds the schema from scratch (DROP SCHEMA … CASCADE) </a:t>
+            </a:r>
+            <a:r>
+              <a:rPr lang="en-US" sz="1300" dirty="0">
+                <a:solidFill>
+                  <a:srgbClr val="6A6A6A"/>
+                </a:solidFill>
+                <a:latin typeface="Calibri" pitchFamily="34" charset="0"/>
+                <a:ea typeface="Calibri" pitchFamily="34" charset="-122"/>
+                <a:cs typeface="Calibri" pitchFamily="34" charset="-120"/>
+                <a:sym typeface="Wingdings" pitchFamily="2" charset="2"/>
+              </a:rPr>
+              <a:t> </a:t>
+            </a:r>
+            <a:r>
+              <a:rPr lang="en-US" sz="1300" dirty="0">
+                <a:solidFill>
+                  <a:srgbClr val="6A6A6A"/>
+                </a:solidFill>
+                <a:latin typeface="Calibri" pitchFamily="34" charset="0"/>
+                <a:ea typeface="Calibri" pitchFamily="34" charset="-122"/>
+                <a:cs typeface="Calibri" pitchFamily="34" charset="-120"/>
+              </a:rPr>
+              <a:t>re-running N times yields the same warehouse. No manual updates, ever: the DW is non-volatile.</a:t>
             </a:r>
             <a:endParaRPr lang="en-US" sz="1400" dirty="0"/>
           </a:p>
@@ -8823,7 +9202,7 @@
           <a:bodyPr wrap="square" lIns="0" tIns="0" rIns="0" bIns="0" rtlCol="0" anchor="ctr"/>
           <a:lstStyle/>
           <a:p>
-            <a:pPr indent="0" marL="0">
+            <a:pPr marL="0" indent="0">
               <a:buNone/>
             </a:pPr>
             <a:r>
@@ -8837,9 +9216,6 @@
               </a:rPr>
               <a:t>Load order = referential integrity — </a:t>
             </a:r>
-            <a:pPr indent="0" marL="0">
-              <a:buNone/>
-            </a:pPr>
             <a:r>
               <a:rPr lang="en-US" sz="1300" dirty="0">
                 <a:solidFill>
@@ -8849,7 +9225,7 @@
                 <a:ea typeface="Calibri" pitchFamily="34" charset="-122"/>
                 <a:cs typeface="Calibri" pitchFamily="34" charset="-120"/>
               </a:rPr>
-              <a:t>dimensions first, then facts, then the bridge: every foreign key must point to an existing surrogate key. FKs are declared and enforced — ETL violations are impossible by construction.</a:t>
+              <a:t>dimensions first, then facts, then the bridge: every foreign key must point to an existing surrogate key. FKs are declared and enforced. ETL violations are impossible by construction.</a:t>
             </a:r>
             <a:endParaRPr lang="en-US" sz="1400" dirty="0"/>
           </a:p>
@@ -8876,7 +9252,7 @@
           <a:bodyPr wrap="square" lIns="0" tIns="0" rIns="0" bIns="0" rtlCol="0" anchor="ctr"/>
           <a:lstStyle/>
           <a:p>
-            <a:pPr indent="0" marL="0">
+            <a:pPr marL="0" indent="0">
               <a:buNone/>
             </a:pPr>
             <a:r>
@@ -8890,9 +9266,6 @@
               </a:rPr>
               <a:t>Every transformation is traceable — </a:t>
             </a:r>
-            <a:pPr indent="0" marL="0">
-              <a:buNone/>
-            </a:pPr>
             <a:r>
               <a:rPr lang="en-US" sz="1300" dirty="0">
                 <a:solidFill>
@@ -8902,7 +9275,7 @@
                 <a:ea typeface="Calibri" pitchFamily="34" charset="-122"/>
                 <a:cs typeface="Calibri" pitchFamily="34" charset="-120"/>
               </a:rPr>
-              <a:t>each code block cites the documented rule it implements (R1–R6, D1–D3, L1–L6). 22,909 facts loaded; 140 facts keep comp_adjusted NULL (countries without a cost index) — kept, not deleted.</a:t>
+              <a:t>each code block cites the documented rule it implements (R1–R6, D1–D3, L1–L6). 22,909 facts loaded; 140 facts keep comp_adjusted NULL (countries without a cost index); kept, not deleted.</a:t>
             </a:r>
             <a:endParaRPr lang="en-US" sz="1400" dirty="0"/>
           </a:p>
@@ -8929,7 +9302,7 @@
           <a:bodyPr wrap="square" lIns="0" tIns="0" rIns="0" bIns="0" rtlCol="0" anchor="ctr"/>
           <a:lstStyle/>
           <a:p>
-            <a:pPr indent="0" marL="0">
+            <a:pPr marL="0" indent="0">
               <a:buNone/>
             </a:pPr>
             <a:r>
@@ -8993,7 +9366,7 @@
           <a:bodyPr wrap="square" lIns="0" tIns="0" rIns="0" bIns="0" rtlCol="0" anchor="ctr"/>
           <a:lstStyle/>
           <a:p>
-            <a:pPr indent="0" marL="0">
+            <a:pPr marL="0" indent="0">
               <a:buNone/>
             </a:pPr>
             <a:r>
@@ -9013,14 +9386,14 @@
       </p:sp>
       <p:pic>
         <p:nvPicPr>
-          <p:cNvPr id="3" name="Image 0" descr="/sessions/gifted-beautiful-cerf/mnt/progetto data/3_presentazione_e_demo/charts/1_top15_purchasing_power.png">    </p:cNvPr>
+          <p:cNvPr id="3" name="Image 0" descr="/sessions/gifted-beautiful-cerf/mnt/progetto data/3_presentazione_e_demo/charts/1_top15_purchasing_power.png"/>
           <p:cNvPicPr>
             <a:picLocks noChangeAspect="1"/>
           </p:cNvPicPr>
           <p:nvPr/>
         </p:nvPicPr>
         <p:blipFill>
-          <a:blip r:embed="rId1"/>
+          <a:blip r:embed="rId3"/>
           <a:stretch>
             <a:fillRect/>
           </a:stretch>
@@ -9056,7 +9429,7 @@
           <a:bodyPr wrap="square" lIns="0" tIns="0" rIns="0" bIns="0" rtlCol="0" anchor="ctr"/>
           <a:lstStyle/>
           <a:p>
-            <a:pPr indent="0" marL="0">
+            <a:pPr marL="0" indent="0">
               <a:buNone/>
             </a:pPr>
             <a:r>
@@ -9095,7 +9468,7 @@
           <a:bodyPr wrap="square" lIns="0" tIns="0" rIns="0" bIns="0" rtlCol="0" anchor="ctr"/>
           <a:lstStyle/>
           <a:p>
-            <a:pPr indent="0" marL="0">
+            <a:pPr marL="0" indent="0">
               <a:buNone/>
             </a:pPr>
             <a:r>
@@ -9134,7 +9507,7 @@
           <a:bodyPr wrap="square" lIns="0" tIns="0" rIns="0" bIns="0" rtlCol="0" anchor="ctr"/>
           <a:lstStyle/>
           <a:p>
-            <a:pPr indent="0" marL="0">
+            <a:pPr marL="0" indent="0">
               <a:spcAft>
                 <a:spcPts val="1000"/>
               </a:spcAft>
@@ -9149,12 +9522,35 @@
                 <a:ea typeface="Calibri" pitchFamily="34" charset="-122"/>
                 <a:cs typeface="Calibri" pitchFamily="34" charset="-120"/>
               </a:rPr>
-              <a:t>Below the top, the ranking reshuffles completely: Georgia 3rd, Poland 6th — ahead of Canada and the UK.</a:t>
+              <a:t>Below the top, the ranking reshuffles completely: Georgia 3rd, Poland 6th </a:t>
+            </a:r>
+            <a:r>
+              <a:rPr lang="en-US" sz="1250" dirty="0">
+                <a:solidFill>
+                  <a:srgbClr val="1A1A1A"/>
+                </a:solidFill>
+                <a:latin typeface="Calibri" pitchFamily="34" charset="0"/>
+                <a:ea typeface="Calibri" pitchFamily="34" charset="-122"/>
+                <a:cs typeface="Calibri" pitchFamily="34" charset="-120"/>
+                <a:sym typeface="Wingdings" pitchFamily="2" charset="2"/>
+              </a:rPr>
+              <a:t></a:t>
+            </a:r>
+            <a:r>
+              <a:rPr lang="en-US" sz="1250" dirty="0">
+                <a:solidFill>
+                  <a:srgbClr val="1A1A1A"/>
+                </a:solidFill>
+                <a:latin typeface="Calibri" pitchFamily="34" charset="0"/>
+                <a:ea typeface="Calibri" pitchFamily="34" charset="-122"/>
+                <a:cs typeface="Calibri" pitchFamily="34" charset="-120"/>
+              </a:rPr>
+              <a:t> ahead of Canada and the UK.</a:t>
             </a:r>
             <a:endParaRPr lang="en-US" sz="1250" dirty="0"/>
           </a:p>
           <a:p>
-            <a:pPr indent="0" marL="0">
+            <a:pPr marL="0" indent="0">
               <a:spcAft>
                 <a:spcPts val="1000"/>
               </a:spcAft>
@@ -9174,7 +9570,7 @@
             <a:endParaRPr lang="en-US" sz="1250" dirty="0"/>
           </a:p>
           <a:p>
-            <a:pPr indent="0" marL="0">
+            <a:pPr marL="0" indent="0">
               <a:spcAft>
                 <a:spcPts val="1000"/>
               </a:spcAft>
@@ -9216,7 +9612,7 @@
           <a:bodyPr wrap="square" lIns="0" tIns="0" rIns="0" bIns="0" rtlCol="0" anchor="ctr"/>
           <a:lstStyle/>
           <a:p>
-            <a:pPr indent="0" marL="0">
+            <a:pPr marL="0" indent="0">
               <a:buNone/>
             </a:pPr>
             <a:r>
@@ -9535,4 +9931,319 @@
     </a:ext>
   </a:extLst>
 </a:theme>
+</file>
+
+<file path=ppt/theme/theme2.xml><?xml version="1.0" encoding="utf-8"?>
+<a:theme xmlns:a="http://schemas.openxmlformats.org/drawingml/2006/main" name="Tema di Office">
+  <a:themeElements>
+    <a:clrScheme name="Office">
+      <a:dk1>
+        <a:sysClr val="windowText" lastClr="000000"/>
+      </a:dk1>
+      <a:lt1>
+        <a:sysClr val="window" lastClr="FFFFFF"/>
+      </a:lt1>
+      <a:dk2>
+        <a:srgbClr val="0E2841"/>
+      </a:dk2>
+      <a:lt2>
+        <a:srgbClr val="E8E8E8"/>
+      </a:lt2>
+      <a:accent1>
+        <a:srgbClr val="156082"/>
+      </a:accent1>
+      <a:accent2>
+        <a:srgbClr val="E97132"/>
+      </a:accent2>
+      <a:accent3>
+        <a:srgbClr val="196B24"/>
+      </a:accent3>
+      <a:accent4>
+        <a:srgbClr val="0F9ED5"/>
+      </a:accent4>
+      <a:accent5>
+        <a:srgbClr val="A02B93"/>
+      </a:accent5>
+      <a:accent6>
+        <a:srgbClr val="4EA72E"/>
+      </a:accent6>
+      <a:hlink>
+        <a:srgbClr val="467886"/>
+      </a:hlink>
+      <a:folHlink>
+        <a:srgbClr val="96607D"/>
+      </a:folHlink>
+    </a:clrScheme>
+    <a:fontScheme name="Office">
+      <a:majorFont>
+        <a:latin typeface="Aptos Display" panose="02110004020202020204"/>
+        <a:ea typeface=""/>
+        <a:cs typeface=""/>
+        <a:font script="Jpan" typeface="游ゴシック Light"/>
+        <a:font script="Hang" typeface="맑은 고딕"/>
+        <a:font script="Hans" typeface="等线 Light"/>
+        <a:font script="Hant" typeface="新細明體"/>
+        <a:font script="Arab" typeface="Times New Roman"/>
+        <a:font script="Hebr" typeface="Times New Roman"/>
+        <a:font script="Thai" typeface="Angsana New"/>
+        <a:font script="Ethi" typeface="Nyala"/>
+        <a:font script="Beng" typeface="Vrinda"/>
+        <a:font script="Gujr" typeface="Shruti"/>
+        <a:font script="Khmr" typeface="MoolBoran"/>
+        <a:font script="Knda" typeface="Tunga"/>
+        <a:font script="Guru" typeface="Raavi"/>
+        <a:font script="Cans" typeface="Euphemia"/>
+        <a:font script="Cher" typeface="Plantagenet Cherokee"/>
+        <a:font script="Yiii" typeface="Microsoft Yi Baiti"/>
+        <a:font script="Tibt" typeface="Microsoft Himalaya"/>
+        <a:font script="Thaa" typeface="MV Boli"/>
+        <a:font script="Deva" typeface="Mangal"/>
+        <a:font script="Telu" typeface="Gautami"/>
+        <a:font script="Taml" typeface="Latha"/>
+        <a:font script="Syrc" typeface="Estrangelo Edessa"/>
+        <a:font script="Orya" typeface="Kalinga"/>
+        <a:font script="Mlym" typeface="Kartika"/>
+        <a:font script="Laoo" typeface="DokChampa"/>
+        <a:font script="Sinh" typeface="Iskoola Pota"/>
+        <a:font script="Mong" typeface="Mongolian Baiti"/>
+        <a:font script="Viet" typeface="Times New Roman"/>
+        <a:font script="Uigh" typeface="Microsoft Uighur"/>
+        <a:font script="Geor" typeface="Sylfaen"/>
+        <a:font script="Armn" typeface="Arial"/>
+        <a:font script="Bugi" typeface="Leelawadee UI"/>
+        <a:font script="Bopo" typeface="Microsoft JhengHei"/>
+        <a:font script="Java" typeface="Javanese Text"/>
+        <a:font script="Lisu" typeface="Segoe UI"/>
+        <a:font script="Mymr" typeface="Myanmar Text"/>
+        <a:font script="Nkoo" typeface="Ebrima"/>
+        <a:font script="Olck" typeface="Nirmala UI"/>
+        <a:font script="Osma" typeface="Ebrima"/>
+        <a:font script="Phag" typeface="Phagspa"/>
+        <a:font script="Syrn" typeface="Estrangelo Edessa"/>
+        <a:font script="Syrj" typeface="Estrangelo Edessa"/>
+        <a:font script="Syre" typeface="Estrangelo Edessa"/>
+        <a:font script="Sora" typeface="Nirmala UI"/>
+        <a:font script="Tale" typeface="Microsoft Tai Le"/>
+        <a:font script="Talu" typeface="Microsoft New Tai Lue"/>
+        <a:font script="Tfng" typeface="Ebrima"/>
+      </a:majorFont>
+      <a:minorFont>
+        <a:latin typeface="Aptos" panose="02110004020202020204"/>
+        <a:ea typeface=""/>
+        <a:cs typeface=""/>
+        <a:font script="Jpan" typeface="游ゴシック"/>
+        <a:font script="Hang" typeface="맑은 고딕"/>
+        <a:font script="Hans" typeface="等线"/>
+        <a:font script="Hant" typeface="新細明體"/>
+        <a:font script="Arab" typeface="Arial"/>
+        <a:font script="Hebr" typeface="Arial"/>
+        <a:font script="Thai" typeface="Cordia New"/>
+        <a:font script="Ethi" typeface="Nyala"/>
+        <a:font script="Beng" typeface="Vrinda"/>
+        <a:font script="Gujr" typeface="Shruti"/>
+        <a:font script="Khmr" typeface="DaunPenh"/>
+        <a:font script="Knda" typeface="Tunga"/>
+        <a:font script="Guru" typeface="Raavi"/>
+        <a:font script="Cans" typeface="Euphemia"/>
+        <a:font script="Cher" typeface="Plantagenet Cherokee"/>
+        <a:font script="Yiii" typeface="Microsoft Yi Baiti"/>
+        <a:font script="Tibt" typeface="Microsoft Himalaya"/>
+        <a:font script="Thaa" typeface="MV Boli"/>
+        <a:font script="Deva" typeface="Mangal"/>
+        <a:font script="Telu" typeface="Gautami"/>
+        <a:font script="Taml" typeface="Latha"/>
+        <a:font script="Syrc" typeface="Estrangelo Edessa"/>
+        <a:font script="Orya" typeface="Kalinga"/>
+        <a:font script="Mlym" typeface="Kartika"/>
+        <a:font script="Laoo" typeface="DokChampa"/>
+        <a:font script="Sinh" typeface="Iskoola Pota"/>
+        <a:font script="Mong" typeface="Mongolian Baiti"/>
+        <a:font script="Viet" typeface="Arial"/>
+        <a:font script="Uigh" typeface="Microsoft Uighur"/>
+        <a:font script="Geor" typeface="Sylfaen"/>
+        <a:font script="Armn" typeface="Arial"/>
+        <a:font script="Bugi" typeface="Leelawadee UI"/>
+        <a:font script="Bopo" typeface="Microsoft JhengHei"/>
+        <a:font script="Java" typeface="Javanese Text"/>
+        <a:font script="Lisu" typeface="Segoe UI"/>
+        <a:font script="Mymr" typeface="Myanmar Text"/>
+        <a:font script="Nkoo" typeface="Ebrima"/>
+        <a:font script="Olck" typeface="Nirmala UI"/>
+        <a:font script="Osma" typeface="Ebrima"/>
+        <a:font script="Phag" typeface="Phagspa"/>
+        <a:font script="Syrn" typeface="Estrangelo Edessa"/>
+        <a:font script="Syrj" typeface="Estrangelo Edessa"/>
+        <a:font script="Syre" typeface="Estrangelo Edessa"/>
+        <a:font script="Sora" typeface="Nirmala UI"/>
+        <a:font script="Tale" typeface="Microsoft Tai Le"/>
+        <a:font script="Talu" typeface="Microsoft New Tai Lue"/>
+        <a:font script="Tfng" typeface="Ebrima"/>
+      </a:minorFont>
+    </a:fontScheme>
+    <a:fmtScheme name="Office">
+      <a:fillStyleLst>
+        <a:solidFill>
+          <a:schemeClr val="phClr"/>
+        </a:solidFill>
+        <a:gradFill rotWithShape="1">
+          <a:gsLst>
+            <a:gs pos="0">
+              <a:schemeClr val="phClr">
+                <a:lumMod val="110000"/>
+                <a:satMod val="105000"/>
+                <a:tint val="67000"/>
+              </a:schemeClr>
+            </a:gs>
+            <a:gs pos="50000">
+              <a:schemeClr val="phClr">
+                <a:lumMod val="105000"/>
+                <a:satMod val="103000"/>
+                <a:tint val="73000"/>
+              </a:schemeClr>
+            </a:gs>
+            <a:gs pos="100000">
+              <a:schemeClr val="phClr">
+                <a:lumMod val="105000"/>
+                <a:satMod val="109000"/>
+                <a:tint val="81000"/>
+              </a:schemeClr>
+            </a:gs>
+          </a:gsLst>
+          <a:lin ang="5400000" scaled="0"/>
+        </a:gradFill>
+        <a:gradFill rotWithShape="1">
+          <a:gsLst>
+            <a:gs pos="0">
+              <a:schemeClr val="phClr">
+                <a:satMod val="103000"/>
+                <a:lumMod val="102000"/>
+                <a:tint val="94000"/>
+              </a:schemeClr>
+            </a:gs>
+            <a:gs pos="50000">
+              <a:schemeClr val="phClr">
+                <a:satMod val="110000"/>
+                <a:lumMod val="100000"/>
+                <a:shade val="100000"/>
+              </a:schemeClr>
+            </a:gs>
+            <a:gs pos="100000">
+              <a:schemeClr val="phClr">
+                <a:lumMod val="99000"/>
+                <a:satMod val="120000"/>
+                <a:shade val="78000"/>
+              </a:schemeClr>
+            </a:gs>
+          </a:gsLst>
+          <a:lin ang="5400000" scaled="0"/>
+        </a:gradFill>
+      </a:fillStyleLst>
+      <a:lnStyleLst>
+        <a:ln w="12700" cap="flat" cmpd="sng" algn="ctr">
+          <a:solidFill>
+            <a:schemeClr val="phClr"/>
+          </a:solidFill>
+          <a:prstDash val="solid"/>
+          <a:miter lim="800000"/>
+        </a:ln>
+        <a:ln w="19050" cap="flat" cmpd="sng" algn="ctr">
+          <a:solidFill>
+            <a:schemeClr val="phClr"/>
+          </a:solidFill>
+          <a:prstDash val="solid"/>
+          <a:miter lim="800000"/>
+        </a:ln>
+        <a:ln w="25400" cap="flat" cmpd="sng" algn="ctr">
+          <a:solidFill>
+            <a:schemeClr val="phClr"/>
+          </a:solidFill>
+          <a:prstDash val="solid"/>
+          <a:miter lim="800000"/>
+        </a:ln>
+      </a:lnStyleLst>
+      <a:effectStyleLst>
+        <a:effectStyle>
+          <a:effectLst/>
+        </a:effectStyle>
+        <a:effectStyle>
+          <a:effectLst/>
+        </a:effectStyle>
+        <a:effectStyle>
+          <a:effectLst>
+            <a:outerShdw blurRad="57150" dist="19050" dir="5400000" algn="ctr" rotWithShape="0">
+              <a:srgbClr val="000000">
+                <a:alpha val="63000"/>
+              </a:srgbClr>
+            </a:outerShdw>
+          </a:effectLst>
+        </a:effectStyle>
+      </a:effectStyleLst>
+      <a:bgFillStyleLst>
+        <a:solidFill>
+          <a:schemeClr val="phClr"/>
+        </a:solidFill>
+        <a:solidFill>
+          <a:schemeClr val="phClr">
+            <a:tint val="95000"/>
+            <a:satMod val="170000"/>
+          </a:schemeClr>
+        </a:solidFill>
+        <a:gradFill rotWithShape="1">
+          <a:gsLst>
+            <a:gs pos="0">
+              <a:schemeClr val="phClr">
+                <a:tint val="93000"/>
+                <a:satMod val="150000"/>
+                <a:shade val="98000"/>
+                <a:lumMod val="102000"/>
+              </a:schemeClr>
+            </a:gs>
+            <a:gs pos="50000">
+              <a:schemeClr val="phClr">
+                <a:tint val="98000"/>
+                <a:satMod val="130000"/>
+                <a:shade val="90000"/>
+                <a:lumMod val="103000"/>
+              </a:schemeClr>
+            </a:gs>
+            <a:gs pos="100000">
+              <a:schemeClr val="phClr">
+                <a:shade val="63000"/>
+                <a:satMod val="120000"/>
+              </a:schemeClr>
+            </a:gs>
+          </a:gsLst>
+          <a:lin ang="5400000" scaled="0"/>
+        </a:gradFill>
+      </a:bgFillStyleLst>
+    </a:fmtScheme>
+  </a:themeElements>
+  <a:objectDefaults>
+    <a:lnDef>
+      <a:spPr/>
+      <a:bodyPr/>
+      <a:lstStyle/>
+      <a:style>
+        <a:lnRef idx="2">
+          <a:schemeClr val="accent1"/>
+        </a:lnRef>
+        <a:fillRef idx="0">
+          <a:schemeClr val="accent1"/>
+        </a:fillRef>
+        <a:effectRef idx="1">
+          <a:schemeClr val="accent1"/>
+        </a:effectRef>
+        <a:fontRef idx="minor">
+          <a:schemeClr val="tx1"/>
+        </a:fontRef>
+      </a:style>
+    </a:lnDef>
+  </a:objectDefaults>
+  <a:extraClrSchemeLst/>
+  <a:extLst>
+    <a:ext uri="{05A4C25C-085E-4340-85A3-A5531E510DB2}">
+      <thm15:themeFamily xmlns:thm15="http://schemas.microsoft.com/office/thememl/2012/main" name="Office Theme" id="{2E142A2C-CD16-42D6-873A-C26D2A0506FA}" vid="{1BDDFF52-6CD6-40A5-AB3C-68EB2F1E4D0A}"/>
+    </a:ext>
+  </a:extLst>
+</a:theme>
 </file>
</xml_diff>